<commit_message>
Explainer deck v0.1.17: 27 slides + adjudication governance slide
Regenerate the explainer deck and script for plugin v0.1.17 (switchable-settings adjudication build).

- BUILD.py: 26 -> 27 slides; new Step 10 governance slide ("You control it"); slide 18 privileged-gate wording (blocked by default, overridable only by a deliberate, logged act); rung A shown as a configurable different-lab model (GPT-5.6 Sol / Gemini / Grok); per-class retirement described as a reversible, audited recommendation.
- Insight-Engine-Explainer.pptx: regenerated from BUILD.py.
- Script.md: updated to 27 slides / v0.1.17 with the new governance narration and renumbered slides.
- Narration.md: new HeyGen-ready per-slide narration file derived from the script.
</commit_message>
<xml_diff>
--- a/Presentation/Insight-Engine-Explainer.pptx
+++ b/Presentation/Insight-Engine-Explainer.pptx
@@ -31,6 +31,7 @@
     <p:sldId id="279" r:id="rId31"/>
     <p:sldId id="280" r:id="rId32"/>
     <p:sldId id="281" r:id="rId33"/>
+    <p:sldId id="282" r:id="rId34"/>
   </p:sldIdLst>
   <p:sldSz cx="12191695" cy="6858000" type="screen4x3"/>
   <p:notesSz cx="6858000" cy="9144000"/>
@@ -527,7 +528,7 @@
           <a:lstStyle/>
           <a:p>
             <a:r>
-              <a:t>This is the Insight Engine — an open plug-in for Claude Code and Cowork, built for analysis you can actually defend. The name is the design. The insight comes from a large language model; the engine is everything wrapped around that model to make its insight verified, graded, and honest about its own limits. It doesn't try to think better than the model — it makes the model show its work, and checks that work against the world. In the next few minutes I'll give you the map of the whole machine on one slide, and then walk it in four movements: the problem it exists for, the idea that answers that problem, the pipeline that carries the idea out — step by step, in the order it actually runs — and then the model layer: which model runs it, the independent adjudication pass we add on top for the highest-stakes work, and the evidence it works.</a:t>
+              <a:t>This is the Insight Engine — a tool for analysis you can actually defend. The idea behind it fits in one sentence: the language model supplies the insight; the engine makes that insight verified, graded, and honest about its own limits. It doesn't try to think better than the model. It makes the model show its work — and checks that work against the world.</a:t>
             </a:r>
           </a:p>
         </p:txBody>
@@ -597,7 +598,7 @@
           <a:lstStyle/>
           <a:p>
             <a:r>
-              <a:t>Which brings us to Step 4: verify what's there. Before we watch it work, here is the vocabulary — the grades that will follow every claim from here on. Every checkable claim gets a V or an N. V, verified, means independently corroborated. N means not independently verified — including when a claim rests only on an interested party's own account. Every V also carries a tier for source strength: V1, confirmed against a primary source; V2, reputable secondary reporting; V3, weak or contested. And one careful distinction: a tier marks how close a source is to the events, not how much to trust it. A company's own incident report is a primary document — but on a claim that company has a stake in, its own paperwork does not earn V1. Independence decides. The banner adds the rule that makes grades mean anything at all: once set, a grade holds — nothing downstream changes it, only restates it; the formal lock comes a few steps on, at Step 7.</a:t>
+              <a:t>Now it verifies. Every claim the conclusion leans on gets sorted into one of three: a public fact that can be checked, a private document only some party holds, or a value that no evidence can settle. The checkable ones are searched and graded. V, for verified, means independently corroborated. N, for not, means not independently verified — including when a claim rests only on an interested party's own account. And every V carries a strength tier — V1 primary, V2 secondary, V3 weak or contested. Here's the part the engine is careful about: a tier marks how close a source is, not how far you should trust it. A company's own incident report is a primary document — but on a claim that company has a stake in, its own paperwork does not earn a V1. That grade has to come from something independent. And once verification is complete — including the disconfirmation pass you'll see next — the grades lock: nothing downstream can change them, only restate them. That's what lets the analysis hold up after the fact.</a:t>
             </a:r>
           </a:p>
         </p:txBody>
@@ -667,7 +668,7 @@
           <a:lstStyle/>
           <a:p>
             <a:r>
-              <a:t>Now watch a single load-bearing claim travel through that machinery. First it is routed, into one of three buckets. A public fact anyone can check goes to search. A private document only some party holds is parked — with a note of exactly which document would settle it. And a judgement call — a value, a framing, a forecast that no search can settle — is never graded at all; it is carried forward to the gate, where you will answer it. Now take the public fact, and watch it get tiered. Searched against independent current sources: the regulation, the official statistic, or the ruling itself is V1; reputable reporting resting on those is V2; weak or disputed independent backing is V3; and nothing independent behind it is N. And here is the principle underneath the tiers — they are graded by independence, not just closeness: a company's own document does not earn V1 on a claim it has a stake in. One step remains before the grade is settled — and it deserves its own slide.</a:t>
+              <a:t>So how does a load-bearing claim get its grade? First it's routed. Is it a public fact you can check, a private document some party holds, or a judgement call — a value, a framing, a forecast — that no search can settle? The judgement call is handed to you; the private document is parked with a note of exactly what would settle it. A public fact gets searched — against independent current sources. If it's backed by a primary source independent of any interested party — the regulation itself, the official statistic, the ruling — that's V1. Reputable reporting resting on those is V2. If independent backing exists but it's weak, or credible sources genuinely disagree, it's V3. If the search turns up nothing independent behind it — including when all it rests on is an interested party's own account — it's N. Then each of those claims is disconfirmed — searched at its own negation, which can pull a grade down — and only then does it lock. That's the machine: route, search, tier by strength and independence, try to break it, lock.</a:t>
             </a:r>
           </a:p>
         </p:txBody>
@@ -737,7 +738,7 @@
           <a:lstStyle/>
           <a:p>
             <a:r>
-              <a:t>That last step is disconfirmation: the engine trying to prove itself wrong. Why, when the claim has just been verified? Because a single confirming search is exactly how a wrong fact survives — you look for support, you find support, you stop. So for every claim the conclusion really rests on, the engine runs a second search aimed at the opposite: it actively hunts for the evidence that would break the claim. If credible counter-evidence of comparable weight turns up, the grade comes down and the dispute is recorded. If a genuine search for the negation finds nothing, the claim is marked as having survived — but only when its support comes from at least two independent sources. If everything traces back to a single origin, echoed from place to place, that is flagged as unopposed, not survived. This is the direct counter to confirmation bias — the failure mode any single-pass search quietly invites. Only after this does the grade stand — the formal lock comes at Step 7.</a:t>
+              <a:t>Grading alone isn't enough, because a single confirming search is exactly how a wrong fact survives. So for every claim the conclusion really rests on, the engine runs a second search — aimed at the opposite. It actively hunts for the evidence that would break the claim. If credible counter-evidence of comparable weight turns up, the claim is downgraded and the dispute is recorded. If a genuine search for the negation finds nothing, the claim is marked as having survived — but only when the support comes from at least two independent sources. If it all traces back to a single origin echoed around, that's flagged as unopposed, not survived. This is the direct counter to confirmation bias — the failure mode any single-pass search quietly invites.</a:t>
             </a:r>
           </a:p>
         </p:txBody>
@@ -807,7 +808,7 @@
           <a:lstStyle/>
           <a:p>
             <a:r>
-              <a:t>So far the engine has treated the problem as a set of claims. But some problems aren't a list of facts — they're a structure that feeds back on itself. When a problem shows two or more signatures of real feedback — loops, delays between cause and effect, things that accumulate, a possible tipping point — the engine adds a conditional systems pass. It maps the causal links, marks the reinforcing and balancing loops, and names where a small push would move the system most. Crucially, the same grading discipline applies to the map, and it holds a hard line: the map is a hypothesis to investigate, not a simulation to trust. It can verify that a loop exists; it will not assert, as established fact, which loop wins — that question routes to you. And it states plainly whose framing the map adopts and who is affected but missing from it. A tidy map that hides its own blind spot is false precision — and the engine treats that as failure, not thoroughness.</a:t>
+              <a:t>Some problems aren't a list of facts — they're a structure that feeds back on itself. When a problem shows more than one signature of real feedback — loops, delays, things that accumulate, a possible tipping point — the engine runs a conditional systems pass. It maps the problem as causal links, marks the reinforcing and balancing loops, and names where a small push would move the most. But it holds a hard line: the map is a hypothesis to investigate, not a simulation to trust. It will tell you a loop exists; it will not tell you, as established fact, which loop wins — that routes back to you. And it states plainly whose framing the map takes and who is affected but missing from it. A tidy map that hides its own blind spot is false precision — and the engine treats that as a failure, not thoroughness.</a:t>
             </a:r>
           </a:p>
         </p:txBody>
@@ -877,7 +878,7 @@
           <a:lstStyle/>
           <a:p>
             <a:r>
-              <a:t>Step 6 is deep-core routing — the hinge between what the engine can settle and what only you can. Running through every hard problem are material questions no amount of evidence can close: how the decision is framed in the first place; the legitimacy question of who is bound by it without a say; the opportunity cost and the alternatives nobody modelled; the value trade-offs. The engine's job here is not to answer these — it is to find them, name them precisely, and put them on an explicit open list. Three rules govern that list: don't resolve them, because you can't; don't drop them, because they are the ones that matter most; and don't assert them as if they were verified facts. They are carried forward, untouched, to the gate at Step 8, where you will answer them. This is what stops the engine quietly smuggling a value judgment in as a finding.</a:t>
+              <a:t>Step 3 deep-core routing.</a:t>
             </a:r>
           </a:p>
         </p:txBody>
@@ -947,7 +948,7 @@
           <a:lstStyle/>
           <a:p>
             <a:r>
-              <a:t>With the open questions set aside, Step 7 makes the analysis defensible in two moves. First, grade-lock: every grade the verification produced is now formally frozen. From here on nothing downstream can change a grade — a later step can only restate it, never quietly soften or upgrade it. That is what lets the analysis hold up after the fact: the confidence on each claim is fixed and auditable. Second, the resilience check: before the engine commits to a call, it stress-tests that call against its own load-bearing assumptions and the key links in the systems map. It asks the blunt question — if this one claim I am leaning on turned out to be wrong, would the call still stand, or does everything hinge on it? A call that rests on a single fragile assumption is flagged as exactly that, so you know how much weight it can bear.</a:t>
+              <a:t>Step 4 grade-lock and resilience.</a:t>
             </a:r>
           </a:p>
         </p:txBody>
@@ -1017,7 +1018,7 @@
           <a:lstStyle/>
           <a:p>
             <a:r>
-              <a:t>You've now heard me say "that routes to you" twice — the judgement calls from grading, and the loop-dominance question from the map. Here is where they all arrive: the gate, the one step the engine refuses to take on your behalf. Underneath every hard problem run questions no evidence can settle — how the decision is framed, who is bound by it without a say, what you are willing to trade against what. The engine separates them out and, instead of answering them, it stops. It puts them to you one at a time, and it will not finalise until you take a position on each — or explicitly defer, which is logged, not ignored. Why force it? Because controlled testing showed that merely showing a decision-maker these questions doesn't work: they read them, then drift back to the verifiable. Being made to answer is what gets them addressed. The engine articulates the questions; you own the judgment.</a:t>
+              <a:t>Then comes the one step the engine refuses to take from you. Running underneath every hard problem are questions no evidence can settle — how the decision is framed, who is bound by it without a say, what you are willing to trade against what. The engine separates those out, and instead of answering them, it stops and hands them to you, one at a time, and won't finalise until you take a position — or explicitly defer, which is logged, not ignored. Why force it? Because controlled testing showed that merely showing a decision-maker these questions doesn't work — they read them, then drift back to the verifiable. Being made to answer is what actually gets them addressed. The engine articulates the questions; you own the judgment.</a:t>
             </a:r>
           </a:p>
         </p:txBody>
@@ -1087,7 +1088,7 @@
           <a:lstStyle/>
           <a:p>
             <a:r>
-              <a:t>With your positions on the record, everything converges into the deliverable: the decision brief — a short decision surface, not an essay. First, the call. Where the problem is wicked, the call is a provisional stance, marked re-openable — because a crisp verdict on a wicked problem would re-import exactly the false closure the engine exists to avoid. Then two kinds of confidence people usually blur, kept deliberately apart: how solid the evidence is — naming the single weakest grade the call leans on — and whether the action will actually work, which can fail even when every fact is solid. Then the one unknown that would most move the answer; the cheapest thing to check next; and what would flip the call, written as a plain condition — "I am treating this as true; if it's false, the call reverses." And one discipline runs throughout: every hedge must name what it depends on. A caveat that points at nothing isn't allowed.</a:t>
+              <a:t>With your positions on the record, it assembles the brief — not an essay, but a short brief you can act on. First the call — and where the problem is wicked, that call is a provisional stance, marked re-openable, not a verdict. Then, kept deliberately apart, two kinds of confidence people usually blur together: how solid the evidence is — naming the single weakest grade the call leans on — and whether the action will actually work, which can fail even when every fact is rock-solid. Then the one unknown that would most move the answer; the cheapest thing to check next; and what would flip the call, written as a plain condition — “I am treating this as true; if it's false, the call reverses.” Every hedge has to name what it depends on. A caveat that points at nothing isn't allowed.</a:t>
             </a:r>
           </a:p>
         </p:txBody>
@@ -1157,7 +1158,7 @@
           <a:lstStyle/>
           <a:p>
             <a:r>
-              <a:t>That completes the core pipeline — triage through the decision brief. But for the highest-stakes work — legal exposure, contested blame, a decision that binds people — the engine can add one more layer on top: Step 10, an opt-in, independent second pass by a separate model, run over the finished analysis. So suppose you've opted in. Here is how it actually runs — the mechanism first, then the choice of adjudicator. It runs as a subagent: a separate agent with its own isolated context. It is handed the facts and the grade-locked spine of the analysis — the claims with their locked grades — but not the first model's reasoning, so it cannot anchor on it. Two passes: blind first — re-derive the analysis and see whether it reaches the same call — then adversarial — try to break the load-bearing claims and the call itself. It hands back a list of discrepancies, which fold in under grade-lock; it never flips the call, and you still own it. Now, which model adjudicates? There is a ladder, strongest first — and one rule across all of it: the adjudicator always checks the finished analysis the Anthropic frontier model produced, and never flips the call itself. The stronger rungs bring in a genuinely different model; the weaker ones re-check with the same one — and the engine always says which. Rung A, the strongest: a frontier model from a different lab — GPT-5.6 Sol, or GPT-5.5 while Sol is in limited preview — because a different training lineage gives the most decorrelated blind spots. It is invoked through an API call to that outside model, and the engine walks you through the set-up step by step, interactively. That rung is built and live-verified as a harness; it is opt-in and off by default, and it is held off entirely for privileged or confidential matters, because the material leaves Anthropic's boundary. Rung B: a different in-house model — Fable 5 — model and context independence, with no external call. Rung C: a panel of two or more blind Opus instances, reading where they diverge — divergence localises the fragile point, but this is a same-model cross-check, not independent adjudication, because every instance shares Opus's blind spots. Rung D, the weakest: a self-adversarial reset in the same session. Every rung is opt-in and costs credits or setup, so nothing runs on its own. And whichever rung runs, the engine declares it — because same-model agreement is stability, not proof.</a:t>
+              <a:t>So how is that second pass actually invoked? As a subagent — a separate agent with its own isolated context, handed the facts and the grade-locked spine from the Anthropic model's analysis, but not that model's reasoning, so it can't anchor on it. Be clear on one thing: adjudication always uses two or more models. The different-lab model never runs on its own — it checks the work of the Anthropic frontier model that produced the analysis. It runs blind first — re-derive, and see if it reaches the same call — then adversarial: try to break the load-bearing claims and the call. It hands back a list of discrepancies, which fold in under grade-lock; you still own the final call. The rung it runs on depends on what is set up, strongest first. Strongest is a different-lab model — GPT-5.6 Sol, or GPT-5.5 while Sol is in limited preview — because a different training lineage gives the most decorrelated blind spots; it is built and live-verified, opt-in and off by default, and blocked by default for confidential or legal matters — overridable only by a deliberate, logged act. Next best is a different in-house model like Fable 5. If neither is set up, run a panel of two or more blind Opus instances and read where they diverge — a same-model cross-check, not independent adjudication. Weakest of all, a self-adversarial reset. Every rung is opt-in and costs credits or setup, so nothing runs on its own. Whichever rung it lands on, the engine should say so — because same-model agreement is stability, not proof.</a:t>
             </a:r>
           </a:p>
         </p:txBody>
@@ -1227,7 +1228,7 @@
           <a:lstStyle/>
           <a:p>
             <a:r>
-              <a:t>One question left in the adjudication chapter: where in the assurance flow does the second pass actually earn its place? Not on the settled facts — a V1 claim, confirmed against a primary source, is done; a second model adds little there. It goes where judgment, not fact, decides the answer: the claims graded weak or uncorroborated, the disconfirmation verdicts, any allocation of blame — which is where legal cases turn — the value questions at the gate, and which loop dominates in a systems map. On that terrain it reliably sharpens: catching where a dominance claim is asserted but not yet established, where an exonerating metric is itself confounded, where an argument quietly contradicts itself — and it does this without reversing a sound call. One caveat from testing: it is verbose. So rank its objections, and surface only the few that would actually change the decision. That closes the adjudication chapter, Step 10. But all of it — the pipeline and the second pass alike — rests on one thing: the model underneath. So, before the last pieces: which model, and when.</a:t>
+              <a:t>That second pass doesn't redo the whole analysis — it goes where judgment, not fact, decides the answer: the claims graded weak or uncorroborated, the disconfirmation verdicts, any allocation of blame, the value questions at the gate, which loop dominates. There it reliably sharpens — catching where a dominance claim isn't yet established, where an exonerating metric is itself confounded, where an argument contradicts itself — and it does so without reversing a sound call. One caveat from testing: it is verbose, so rank its objections and surface only the few that would actually change the decision.</a:t>
             </a:r>
           </a:p>
         </p:txBody>
@@ -1297,7 +1298,7 @@
           <a:lstStyle/>
           <a:p>
             <a:r>
-              <a:t>Before we walk it, here is the map. The Insight Engine is one architecture with four parts, and each part gets its own chapter in the slides that follow. First, the idea: two jobs and one rule — reveal what's hidden, verify what's there, and the value calls stay yours. Second, the pipeline that carries the idea out: triage sets the effort; provocation surfaces what hides; verification grades and holds every load-bearing claim, with a disconfirmation pass that tries to break them; a conditional systems pass maps feedback; the forced gate puts the un-settleable questions to you; and a decision brief carries the result. Third, the interface: five commands, from analyse, which runs everything, to adjudicate. And fourth, the model layer: a frontier model executes, and for the highest-stakes work an independent adjudication pass sits on top — opt-in, off by default. The whole architecture is built around ICD 203, the U.S. intelligence community's analytic standards. Now — the problem.</a:t>
+              <a:t>Before we walk it, here is the map.</a:t>
             </a:r>
           </a:p>
         </p:txBody>
@@ -1367,7 +1368,7 @@
           <a:lstStyle/>
           <a:p>
             <a:r>
-              <a:t>Step back now to the choice underneath all of it: which model, and when — because the engine is scaffolding, and something has to fill it. For execution, it is designed for a top-tier frontier model: nearly every step you've seen leans on the model's own reasoning — judging a source, running a real search for counter-evidence, catching its own confident mistakes. In building the engine, we ran it on Opus 4.8. And for the adjudication pass you've just seen, a second, independent frontier model, brought in to check the finished analysis. In our own testing we used Fable 5 — rung B of the ladder — run blind first, then adversarially. The honest, tested framing is worth stating plainly, now that you've seen how the second pass runs and where it helps: treat it as a rigour-and-defensibility check, not a safety net. It sharpens a sound analysis, safely; whether it can catch an error the disciplined first pass missed is unproven — in our own testing, the first pass already caught the constructible ones. But all of this assumes a capable model underneath.</a:t>
+              <a:t>One more thing about that second pass before we step back to the model itself: you are in control of all of it, and it is honest about when it is not needed. Every part is switchable, and nothing is locked — whether it is offered at all, which rung runs, how many Opus instances, how many different labs, how many runs each. All yours to set, standing or per run. The governance is asked-first: before anything leaves Anthropic's boundary, the engine asks whether the matter is privileged or confidential, and shows you the exact redacted package to confirm, edit, or cancel. A privileged block is the default, and it lifts only by a deliberate, logged act — never silently. This is a personal-use tool: you own even the boundary decision. And the layer is honest about its own worth: every real run is logged to a use-monitor, and a pre-registered, per-class rule reads that ledger — if a whole class of problem shows no decision-relevant catches over enough runs, the rule recommends demoting adjudication to on-request for that class — reversible, and still spot-audited — deciding from real use rather than argument where it no longer adds decision value.</a:t>
             </a:r>
           </a:p>
         </p:txBody>
@@ -1437,7 +1438,7 @@
           <a:lstStyle/>
           <a:p>
             <a:r>
-              <a:t>What happens if you run the engine on a weaker model? The scaffolding survives. The gate still makes you own the value calls; the grades and caveats still travel with every claim; rendering still refuses to drop them. But what fills that scaffold degrades. A weaker model grades sources less reliably, runs a thinner search for counter-evidence, and carries more confident errors while being worse at catching them — and the engine relies on the model catching itself. So the warning is worth stating plainly: the engine cannot add reasoning the model doesn't have. It disciplines and exposes the model's work; it does not rescue it. And the polish is itself a risk — the grades and the caveats can make a weak answer look more defensible than it really is. The assurance is only ever as good as the model underneath it.</a:t>
+              <a:t>One practical question: which model should run this? The engine is designed for a strong model — a top-tier frontier model for execution, because nearly every step leans on the model's own reasoning: judging a source, running a real search for counter-evidence, catching its own confident mistakes. In building the engine we ran it on Opus 4.8. But for the highest-stakes work — legal exposure, contested blame, a decision that binds people — add a second pass: a different frontier model, brought in to adjudicate. We used Fable 5. Here's the honest, tested part: its benefit at catching an error the disciplined first pass missed is unproven — on our own testing, the first pass already caught the constructible ones. What the second pass does do, reliably and safely, is sharpen a sound analysis: it flags where a load-bearing claim isn't yet established, without corrupting a correct call. Treat it as a rigour-and-defensibility check, not a safety net.</a:t>
             </a:r>
           </a:p>
         </p:txBody>
@@ -1507,7 +1508,7 @@
           <a:lstStyle/>
           <a:p>
             <a:r>
-              <a:t>You have now seen the whole engine — the pipeline, the independent second pass, and what it all rests on. Here is the practical chapter: how you actually drive it. The interface is five commands. Analyse runs everything you've just seen. Verify runs the fact-checking layer on its own — a set of claims, or a single premise you want pressure-tested before relying on it. Render re-voices a finished analysis for a particular reader — a board, a regulator, opposing counsel, a family — without ever changing a claim or a grade to suit the audience, and carrying a core of caveats no version is allowed to drop: that is the grade-lock doing its job downstream. Track keeps a long-running investigation alive as new facts arrive, re-verifying the graded claims and telling you if the call has moved. And adjudicate is the independent second pass you have just seen in depth — the opt-in, off-by-default capstone of the assurance architecture. Two of these commands — render and track — are the final two pipeline steps, and they are next.</a:t>
+              <a:t>And the other direction — what if you run it on a weaker model? The scaffolding survives: the gate still makes you own the value calls, the grades and caveats still travel. But what fills that scaffold degrades. A weaker model grades sources less reliably, runs a thinner search for counter-evidence, and carries more confident errors while being worse at catching them — and the engine relies on the model catching itself. The warning worth stating plainly: the engine cannot add reasoning the model doesn't have. It disciplines and exposes the model's work; it does not rescue it. And its own polish is a risk — the grades and caveats can make a weak answer look more defensible than it is. The assurance is only ever as good as the model underneath it.</a:t>
             </a:r>
           </a:p>
         </p:txBody>
@@ -1577,7 +1578,7 @@
           <a:lstStyle/>
           <a:p>
             <a:r>
-              <a:t>Two pipeline steps remain, and both begin only after the call is made. The first is render — Step eleven. It re-voices the finished analysis for whoever must read it: a board, a regulator, opposing counsel, a family. It never changes a claim or a grade to suit the audience — it is a register transform only — and it carries a core of caveats that no version is allowed to drop. So the same graded analysis can be re-expressed for any reader who needs it, without softening for any of them.</a:t>
+              <a:t>All of this runs through five commands. Analyse runs the whole pipeline you've just seen. Verify runs the fact-checking layer on its own — a set of claims, or a single premise you want pressure-tested. Render re-voices a finished analysis for a particular reader — a board, a regulator, opposing counsel, a family — without ever changing a claim or a grade to suit the audience, and carrying a core of caveats no version is allowed to drop. Track keeps an investigation alive as new facts arrive, re-verifying the spine and telling you if the call has moved. And adjudicate is the opt-in independent second pass — the L4.5 layer — that brings in one or more separate models to check a finished high-stakes analysis.</a:t>
             </a:r>
           </a:p>
         </p:txBody>
@@ -1647,7 +1648,7 @@
           <a:lstStyle/>
           <a:p>
             <a:r>
-              <a:t>The second is track — Step twelve. It keeps a long-running investigation alive as new facts arrive: it re-verifies the grade-locked spine as fresh evidence lands, and tells you plainly if the call has moved. So the analysis does not simply end at the brief; it is kept current as the world changes. That completes the twelve steps. One thing is left to say — where this whole discipline comes from.</a:t>
+              <a:t>S14b render note</a:t>
             </a:r>
           </a:p>
         </p:txBody>
@@ -1717,7 +1718,7 @@
           <a:lstStyle/>
           <a:p>
             <a:r>
-              <a:t>Which leaves the last question: where does this discipline come from, and is there evidence it works? None of it is invented from nothing. The engine is architected around ICD 203 — the U.S. intelligence community's Analytic Standards directive — and specifically its nine analytic tradecraft standards: describing the quality of sources, expressing uncertainty, separating evidence from judgment, weighing alternatives. You have seen each of those in this walkthrough — in the tiers, the caveats, and the gate. In a blind assessment against those nine standards, the engine scored ninety-two percent, where a strong model unaided scored seventy-five. And to be honest about what that number is: the engine is architected around the standards and was assessed once — this is not a formal certification. The ninety-two percent is a signal, not a seal. But it points the same way as everything else you've seen: discipline, made checkable.</a:t>
+              <a:t>S14c track note</a:t>
             </a:r>
           </a:p>
         </p:txBody>
@@ -1787,7 +1788,77 @@
           <a:lstStyle/>
           <a:p>
             <a:r>
-              <a:t>So that is the Insight Engine: a language model for the insight, and around it a pipeline that reveals what hides, verifies what's there, and hands the judgment back to you. It's an open plug-in for Claude Code and Cowork — the repository is on the screen. Bring it your hardest problem. Hand it something real, let the gate make you take a position, and get back an analysis you can stand behind — not because it sounds confident, but because every claim in it shows its grade, its source, and what would change it.</a:t>
+              <a:t>None of this is invented from nothing. The engine is architected around ICD 203 — the U.S. intelligence community's Analytic Standards directive — and specifically its nine analytic tradecraft standards: describing the quality of sources, expressing uncertainty, separating evidence from judgment, weighing alternatives. In a blind assessment against those nine standards, the engine scored ninety-two percent, where a strong model unaided scored seventy-five. To be honest about what that is: it's architected around ICD 203 and assessed once — not a formal certification. The number is a signal, not a seal.</a:t>
+            </a:r>
+          </a:p>
+        </p:txBody>
+      </p:sp>
+      <p:sp>
+        <p:nvSpPr>
+          <p:cNvPr id="4" name="Slide Number Placeholder 3"/>
+          <p:cNvSpPr>
+            <a:spLocks noGrp="1"/>
+          </p:cNvSpPr>
+          <p:nvPr>
+            <p:ph type="sldNum" idx="5" sz="quarter"/>
+          </p:nvPr>
+        </p:nvSpPr>
+        <p:spPr/>
+      </p:sp>
+    </p:spTree>
+  </p:cSld>
+  <p:clrMapOvr>
+    <a:masterClrMapping/>
+  </p:clrMapOvr>
+</p:notes>
+</file>
+
+<file path=ppt/notesSlides/notesSlide27.xml><?xml version="1.0" encoding="utf-8"?>
+<p:notes xmlns:a="http://schemas.openxmlformats.org/drawingml/2006/main" xmlns:p="http://schemas.openxmlformats.org/presentationml/2006/main" xmlns:r="http://schemas.openxmlformats.org/officeDocument/2006/relationships">
+  <p:cSld>
+    <p:spTree>
+      <p:nvGrpSpPr>
+        <p:cNvPr id="1" name=""/>
+        <p:cNvGrpSpPr/>
+        <p:nvPr/>
+      </p:nvGrpSpPr>
+      <p:grpSpPr>
+        <a:xfrm>
+          <a:off x="0" y="0"/>
+          <a:ext cx="0" cy="0"/>
+          <a:chOff x="0" y="0"/>
+          <a:chExt cx="0" cy="0"/>
+        </a:xfrm>
+      </p:grpSpPr>
+      <p:sp>
+        <p:nvSpPr>
+          <p:cNvPr id="2" name="Slide Image Placeholder 1"/>
+          <p:cNvSpPr>
+            <a:spLocks noGrp="1"/>
+          </p:cNvSpPr>
+          <p:nvPr>
+            <p:ph type="sldImg" idx="2"/>
+          </p:nvPr>
+        </p:nvSpPr>
+        <p:spPr/>
+      </p:sp>
+      <p:sp>
+        <p:nvSpPr>
+          <p:cNvPr id="3" name="Notes Placeholder 2"/>
+          <p:cNvSpPr>
+            <a:spLocks noGrp="1"/>
+          </p:cNvSpPr>
+          <p:nvPr>
+            <p:ph type="body" idx="3" sz="quarter"/>
+          </p:nvPr>
+        </p:nvSpPr>
+        <p:spPr/>
+        <p:txBody>
+          <a:bodyPr/>
+          <a:lstStyle/>
+          <a:p>
+            <a:r>
+              <a:t>So — bring it your hardest problem. It's an open plug-in for Claude Code and Cowork. Hand it a real problem, let the gate make you take a position, and get back an analysis you can stand behind.</a:t>
             </a:r>
           </a:p>
         </p:txBody>
@@ -1857,7 +1928,7 @@
           <a:lstStyle/>
           <a:p>
             <a:r>
-              <a:t>The name tells you the design. “Insight” is the first half — and that comes entirely from the model. A strong large language model supplies the raw material: the reasoning, the reading of the documents, the first draft of an answer, the searches. The engine adds none of that intelligence; it assumes it. “Engine” is the second half — and that is everything wrapped around the model to make its insight trustworthy, in rising order. Verification: it checks what can be checked against the world. Assurance: it grades how strongly each claim stands and locks those grades, so the confidence is explicit and cannot drift. And adjudication: for the highest-stakes work, it brings in a second, independent model to check the finished analysis. Insight from the model; verification, assurance, and adjudication from the engine.</a:t>
+              <a:t>Insight from the model; verification, assurance, and adjudication from the engine.</a:t>
             </a:r>
           </a:p>
         </p:txBody>
@@ -1927,7 +1998,7 @@
           <a:lstStyle/>
           <a:p>
             <a:r>
-              <a:t>Start with the problem: a confident guess is not verified evidence. The engine is aimed at high-stakes, complex, or wicked problems — "wicked" meaning there is no clean, checkable solution. These problems share three features, and each defeats ordinary analysis in its own way. First, the things that matter most hide — they sit exactly where attention doesn't naturally go. Second, the evidence is mixed: sources disagree, and some of them have a stake in the answer. Third, the questions that actually decide the outcome are value judgments, which no amount of research can settle for you. Now hand a problem like that to a strong language model, and you get a fluent, confident answer. That is the trap. Fluent is not the same as verified — and certainly not the same as defensible. Keep those three features in mind: they are the specification the engine was built against.</a:t>
+              <a:t>A confident guess is not verified evidence. High-stakes, complex, or wicked problems — the ones with no clean solution — tend to share three features. The things that matter most hide — they sit where attention doesn't naturally go. The evidence is mixed, or it comes from people with a stake in the answer. And the questions that actually decide the outcome are value judgments, which no amount of analysis can settle for you. Hand a problem like that to a strong model and you get a fluent, confident answer. But fluent isn't the same as verified — and it certainly isn't the same as defensible.</a:t>
             </a:r>
           </a:p>
         </p:txBody>
@@ -1997,7 +2068,7 @@
           <a:lstStyle/>
           <a:p>
             <a:r>
-              <a:t>And each of those three features gets an answer — which gives the engine its shape: two jobs, plus one rule. Job one answers the hiding: reveal what's hidden. The voice that's absent from the sources. The fact that's been normalised until nobody questions it. The thing left conspicuously out — some of it simply missed, some kept out of view on purpose. Job two answers the mixed evidence: verify what's there. Check everything that can be checked, grade how strongly each checkable claim stands, and then try to break its own findings. And the rule answers the value judgments: the engine will not quietly make them for you. It makes you take them — explicitly, on the record. Seeing, checking, and owning the judgment. Hold on to those three, because every step you are about to see serves one of them.</a:t>
+              <a:t>So the engine's move isn't to be smarter — it's to be more honest, and it has two jobs, not one. The first is to reveal what's hidden: the voice that's absent, the fact that's been normalised until no one questions it, the thing left conspicuously out — some of it simply missed, some kept out of view on purpose. The second is to verify what's there: check what can be checked, grade how strongly each checkable claim stands, and try to break its own findings. Seeing and checking — and then it makes you own the value calls, instead of quietly making them for you. Everything that follows serves those two jobs.</a:t>
             </a:r>
           </a:p>
         </p:txBody>
@@ -2067,7 +2138,7 @@
           <a:lstStyle/>
           <a:p>
             <a:r>
-              <a:t>Here is the whole machine on one slide, so you can see where we're going before we walk it. You hand it a problem. Triage decides how much effort the problem deserves. It offers a quick, optional chance to scope the problem. The provocation pass surfaces what hides. Verification grades every claim the conclusion leans on. A conditional systems pass runs only when the problem feeds back on itself. "Deep-core" is the engine's name for the questions no evidence can settle — it sets those aside rather than answering them. Grade-lock freezes the evidence grades, so nothing downstream can soften them. Then comes the one step that is yours — the gate, where those set-aside questions are put to you. And finally, a decision brief you can act on. And above all of this, for the highest-stakes work, sits the layer you saw on the map — an opt-in, independent adjudication pass by a second model, which gets its own chapter later. That is nine pipeline steps; then three more on top — adjudication, and the two follow-ons that re-voice and maintain the finished analysis: render, then track. Twelve in all, running silently except one, the gate. Let's take them in order, starting with triage.</a:t>
+              <a:t>S4 overview note</a:t>
             </a:r>
           </a:p>
         </p:txBody>
@@ -2137,7 +2208,7 @@
           <a:lstStyle/>
           <a:p>
             <a:r>
-              <a:t>Triage answers a simple question: how hard should the engine look? Not every question deserves the full machine — but the call is deliberately fail-safe, and depth is the default. The engine gives a short, proportionate answer only when a problem is unambiguously routine, reversible, and binds nobody. Any single warning sign is enough to run everything: something irreversible; someone bound by the outcome who isn't in the room; real money or dependency; legal or regulatory exposure; contested values; or a party who benefits from light scrutiny. Notice that last one — the engine is suspicious of the framing itself, asking "am I being invited to treat this as routine?" The reasoning behind the design is on the banner: a little over-analysis is cheap; treating a serious problem as routine is not. With the effort sized, the engine offers you an optional chance to scope the problem — Step 2.</a:t>
+              <a:t>The first thing it does is decide how hard to look. Not every question deserves the full machine — but that call is deliberately fail-safe. Depth is the default. It only scales down when a problem is unambiguously routine, reversible, and binds nobody. If there's any doubt at all — anything irreversible, anyone affected who isn't in the room, real money, legal exposure, or a party who benefits from light scrutiny — it runs the full method. A little over-analysis is cheap. Treating a serious problem as routine is not.</a:t>
             </a:r>
           </a:p>
         </p:txBody>
@@ -2207,7 +2278,7 @@
           <a:lstStyle/>
           <a:p>
             <a:r>
-              <a:t>Step 2 is optional scoping — a quick chance for you to sharpen the problem before the engine digs in. It offers up to five clarifying questions, one thing each, and every one is skippable. What is the trouble, stated as the symptom and not a diagnosis, and why now? Whose problem is it, who will act on the answer, and who else will read it? What would a good outcome look like, what counts as a serious cost, and whose costs matter most? What is fixed, and what is explicitly in and out of scope — because scope is where the largest hidden things hide. And is there any material only you hold, a document or a figure that cannot be checked online, which you can upload. Skip any or all of it; nothing is blocked. Whatever you do not answer, the engine fills with a stated assumption and marks it plainly as one, so the gaps are visible rather than hidden.</a:t>
+              <a:t>S5b scoping note</a:t>
             </a:r>
           </a:p>
         </p:txBody>
@@ -2277,7 +2348,7 @@
           <a:lstStyle/>
           <a:p>
             <a:r>
-              <a:t>With the problem scoped, the analysis opens at Step 3 — the provocation pass: revealing what's hidden — deliberately before any verification, because you cannot verify a claim you never noticed. This is the provocation pass: a disciplined set of probes, a couple always run and the rest chosen to fit the case. Whose voice is absent — who is affected but nowhere in the sources? Who benefits from the way the problem has been framed? What is being treated as normal that shouldn't be? And the hardest probe of all: what is conspicuously missing — the document that isn't there, the question nobody asked? Some of what hides is simply overlooked; some is kept out of view by someone it would inconvenience. Either way, the goal is to make the invisible visible. Then it steelmans its strongest findings — builds the best case against them — and names everyone the outcome materially touches, including those not in the room. That produces a set of claims. Now those claims have to be checked.</a:t>
+              <a:t>Then, before it verifies anything, it goes hunting for your blind spots — the things a fluent first reading glides straight past. This is the provocation pass — a disciplined set of probes, a couple always run and the rest chosen to fit the case, aimed at what the page hides and at what it quietly smuggles in. Whose voice is absent? Who benefits from the way the problem's been framed? What's being treated as normal that shouldn't be? And hardest of all — what's conspicuously missing: the document that isn't there, the question nobody asked? Some of what matters is simply overlooked; some is kept out of view by someone it would inconvenience. Either way, the engine's job here is to make the invisible visible — then it steelmans your strongest findings and names everyone the outcome materially touches, including those not in the room — so you decide with the whole picture, not the convenient part of it.</a:t>
             </a:r>
           </a:p>
         </p:txBody>
@@ -5464,7 +5535,7 @@
                 </a:solidFill>
                 <a:latin typeface="Arial"/>
               </a:rPr>
-              <a:t>An open plugin for Claude Code &amp; Cowork   ·   v0.1.16</a:t>
+              <a:t>An open plugin for Claude Code &amp; Cowork   ·   v0.1.17</a:t>
             </a:r>
           </a:p>
         </p:txBody>
@@ -5499,7 +5570,7 @@
                 </a:solidFill>
                 <a:latin typeface="Arial"/>
               </a:rPr>
-              <a:t>1/26</a:t>
+              <a:t>1/27</a:t>
             </a:r>
           </a:p>
         </p:txBody>
@@ -6339,7 +6410,7 @@
                 </a:solidFill>
                 <a:latin typeface="Arial"/>
               </a:rPr>
-              <a:t>10/26</a:t>
+              <a:t>10/27</a:t>
             </a:r>
           </a:p>
         </p:txBody>
@@ -7336,7 +7407,7 @@
                 </a:solidFill>
                 <a:latin typeface="Arial"/>
               </a:rPr>
-              <a:t>11/26</a:t>
+              <a:t>11/27</a:t>
             </a:r>
           </a:p>
         </p:txBody>
@@ -7997,7 +8068,7 @@
                 </a:solidFill>
                 <a:latin typeface="Arial"/>
               </a:rPr>
-              <a:t>12/26</a:t>
+              <a:t>12/27</a:t>
             </a:r>
           </a:p>
         </p:txBody>
@@ -8541,7 +8612,7 @@
                 </a:solidFill>
                 <a:latin typeface="Arial"/>
               </a:rPr>
-              <a:t>13/26</a:t>
+              <a:t>13/27</a:t>
             </a:r>
           </a:p>
         </p:txBody>
@@ -9089,7 +9160,7 @@
                 </a:solidFill>
                 <a:latin typeface="Arial"/>
               </a:rPr>
-              <a:t>14/26</a:t>
+              <a:t>14/27</a:t>
             </a:r>
           </a:p>
         </p:txBody>
@@ -9537,7 +9608,7 @@
                 </a:solidFill>
                 <a:latin typeface="Arial"/>
               </a:rPr>
-              <a:t>15/26</a:t>
+              <a:t>15/27</a:t>
             </a:r>
           </a:p>
         </p:txBody>
@@ -9831,7 +9902,7 @@
                 </a:solidFill>
                 <a:latin typeface="Arial"/>
               </a:rPr>
-              <a:t>16/26</a:t>
+              <a:t>16/27</a:t>
             </a:r>
           </a:p>
         </p:txBody>
@@ -10763,7 +10834,7 @@
                 </a:solidFill>
                 <a:latin typeface="Arial"/>
               </a:rPr>
-              <a:t>17/26</a:t>
+              <a:t>17/27</a:t>
             </a:r>
           </a:p>
         </p:txBody>
@@ -11167,7 +11238,7 @@
                 </a:solidFill>
                 <a:latin typeface="Arial"/>
               </a:rPr>
-              <a:t>A · different-LAB model (GPT-5.6 Sol; interim GPT-5.5) — strongest; runs ALONGSIDE the Anthropic model, never alone. Invoked by an API call — the engine guides the set-up interactively. </a:t>
+              <a:t>A · different-LAB model (configurable — GPT-5.6 Sol, Gemini, or Grok) — strongest; runs ALONGSIDE the Anthropic model, never alone. Invoked by an API call — the engine guides the set-up interactively. </a:t>
             </a:r>
             <a:r>
               <a:rPr sz="1300" b="0" i="1">
@@ -11176,7 +11247,7 @@
                 </a:solidFill>
                 <a:latin typeface="Arial"/>
               </a:rPr>
-              <a:t>Built + live-verified as a harness; opt-in, off by default; data leaves the boundary, off for privileged/confidential matters.</a:t>
+              <a:t>Built + live-verified as a harness; opt-in, off by default; data leaves the boundary, so privileged/confidential is blocked by default — overridable only by a deliberate, logged act.</a:t>
             </a:r>
           </a:p>
           <a:p>
@@ -11352,7 +11423,7 @@
                 </a:solidFill>
                 <a:latin typeface="Arial"/>
               </a:rPr>
-              <a:t>18/26</a:t>
+              <a:t>18/27</a:t>
             </a:r>
           </a:p>
         </p:txBody>
@@ -11880,7 +11951,7 @@
                 </a:solidFill>
                 <a:latin typeface="Arial"/>
               </a:rPr>
-              <a:t>19/26</a:t>
+              <a:t>19/27</a:t>
             </a:r>
           </a:p>
         </p:txBody>
@@ -12576,7 +12647,7 @@
                 </a:solidFill>
                 <a:latin typeface="Arial"/>
               </a:rPr>
-              <a:t>2/26</a:t>
+              <a:t>2/27</a:t>
             </a:r>
           </a:p>
         </p:txBody>
@@ -12637,7 +12708,7 @@
                 </a:solidFill>
                 <a:latin typeface="Arial"/>
               </a:rPr>
-              <a:t>MODEL CHOICE · WHICH MODEL, AND WHEN</a:t>
+              <a:t>STEP 10 · ADJUDICATION · YOU CONTROL IT</a:t>
             </a:r>
           </a:p>
         </p:txBody>
@@ -12672,7 +12743,7 @@
                 </a:solidFill>
                 <a:latin typeface="Arial"/>
               </a:rPr>
-              <a:t>Which model, and when.</a:t>
+              <a:t>Every gate is yours to set — and it retires itself.</a:t>
             </a:r>
           </a:p>
         </p:txBody>
@@ -12686,7 +12757,7 @@
         <p:spPr>
           <a:xfrm>
             <a:off x="640080" y="1783080"/>
-            <a:ext cx="5440680" cy="2788920"/>
+            <a:ext cx="5440680" cy="3063240"/>
           </a:xfrm>
           <a:prstGeom prst="roundRect">
             <a:avLst>
@@ -12734,28 +12805,28 @@
         <p:spPr>
           <a:xfrm>
             <a:off x="914400" y="2011680"/>
-            <a:ext cx="4937760" cy="822960"/>
-          </a:xfrm>
-          <a:prstGeom prst="rect">
-            <a:avLst/>
-          </a:prstGeom>
-          <a:noFill/>
-        </p:spPr>
-        <p:txBody>
-          <a:bodyPr wrap="square" anchor="t" lIns="0" rIns="0" tIns="0" bIns="0">
-            <a:spAutoFit/>
-          </a:bodyPr>
-          <a:lstStyle/>
-          <a:p>
-            <a:pPr algn="l"/>
-            <a:r>
-              <a:rPr sz="1900" b="1" i="0">
+            <a:ext cx="4937760" cy="457200"/>
+          </a:xfrm>
+          <a:prstGeom prst="rect">
+            <a:avLst/>
+          </a:prstGeom>
+          <a:noFill/>
+        </p:spPr>
+        <p:txBody>
+          <a:bodyPr wrap="square" anchor="t" lIns="0" rIns="0" tIns="0" bIns="0">
+            <a:spAutoFit/>
+          </a:bodyPr>
+          <a:lstStyle/>
+          <a:p>
+            <a:pPr algn="l"/>
+            <a:r>
+              <a:rPr sz="1800" b="1" i="0">
                 <a:solidFill>
                   <a:srgbClr val="4E79A6"/>
                 </a:solidFill>
                 <a:latin typeface="Arial"/>
               </a:rPr>
-              <a:t>Execution — a top-tier frontier model</a:t>
+              <a:t>Switchable — nothing is locked</a:t>
             </a:r>
           </a:p>
         </p:txBody>
@@ -12768,8 +12839,8 @@
         </p:nvSpPr>
         <p:spPr>
           <a:xfrm>
-            <a:off x="914400" y="3246120"/>
-            <a:ext cx="4937760" cy="1280160"/>
+            <a:off x="914400" y="2651760"/>
+            <a:ext cx="4937760" cy="2103120"/>
           </a:xfrm>
           <a:prstGeom prst="rect">
             <a:avLst/>
@@ -12788,13 +12859,13 @@
               </a:spcAft>
             </a:pPr>
             <a:r>
-              <a:rPr sz="1600" b="0" i="0">
+              <a:rPr sz="1400" b="0" i="0">
                 <a:solidFill>
                   <a:srgbClr val="141413"/>
                 </a:solidFill>
                 <a:latin typeface="Arial"/>
               </a:rPr>
-              <a:t>Nearly every step leans on the model's own reasoning.</a:t>
+              <a:t>• offer or not; which rung; panel size N, labs M, runs R</a:t>
             </a:r>
           </a:p>
           <a:p>
@@ -12804,13 +12875,61 @@
               </a:spcAft>
             </a:pPr>
             <a:r>
-              <a:rPr sz="1600" b="1" i="0">
-                <a:solidFill>
-                  <a:srgbClr val="4E79A6"/>
-                </a:solidFill>
-                <a:latin typeface="Arial"/>
-              </a:rPr>
-              <a:t>We ran the engine on Opus 4.8.</a:t>
+              <a:rPr sz="1400" b="0" i="0">
+                <a:solidFill>
+                  <a:srgbClr val="141413"/>
+                </a:solidFill>
+                <a:latin typeface="Arial"/>
+              </a:rPr>
+              <a:t>• the privilege / egress gate is asked before anything leaves the boundary</a:t>
+            </a:r>
+          </a:p>
+          <a:p>
+            <a:pPr algn="l">
+              <a:spcAft>
+                <a:spcPts val="600"/>
+              </a:spcAft>
+            </a:pPr>
+            <a:r>
+              <a:rPr sz="1400" b="0" i="0">
+                <a:solidFill>
+                  <a:srgbClr val="141413"/>
+                </a:solidFill>
+                <a:latin typeface="Arial"/>
+              </a:rPr>
+              <a:t>• a block lifts only by a deliberate, logged act — never silently</a:t>
+            </a:r>
+          </a:p>
+          <a:p>
+            <a:pPr algn="l">
+              <a:spcAft>
+                <a:spcPts val="600"/>
+              </a:spcAft>
+            </a:pPr>
+            <a:r>
+              <a:rPr sz="1400" b="0" i="0">
+                <a:solidFill>
+                  <a:srgbClr val="141413"/>
+                </a:solidFill>
+                <a:latin typeface="Arial"/>
+              </a:rPr>
+              <a:t>• the exact redacted package is shown to confirm / edit / cancel</a:t>
+            </a:r>
+          </a:p>
+          <a:p>
+            <a:pPr algn="l">
+              <a:spcAft>
+                <a:spcPts val="600"/>
+              </a:spcAft>
+            </a:pPr>
+            <a:r>
+              <a:rPr sz="1400" b="0" i="0">
+                <a:solidFill>
+                  <a:srgbClr val="141413"/>
+                </a:solidFill>
+                <a:latin typeface="Arial"/>
+              </a:rPr>
+              <a:t>• every setting standing or per-run; personal-use, nothing centrally locked</a:t>
             </a:r>
           </a:p>
         </p:txBody>
@@ -12824,7 +12943,7 @@
         <p:spPr>
           <a:xfrm>
             <a:off x="6263640" y="1783080"/>
-            <a:ext cx="5285232" cy="2788920"/>
+            <a:ext cx="5285232" cy="3063240"/>
           </a:xfrm>
           <a:prstGeom prst="roundRect">
             <a:avLst>
@@ -12872,28 +12991,28 @@
         <p:spPr>
           <a:xfrm>
             <a:off x="6537960" y="2011680"/>
-            <a:ext cx="4754880" cy="822960"/>
-          </a:xfrm>
-          <a:prstGeom prst="rect">
-            <a:avLst/>
-          </a:prstGeom>
-          <a:noFill/>
-        </p:spPr>
-        <p:txBody>
-          <a:bodyPr wrap="square" anchor="t" lIns="0" rIns="0" tIns="0" bIns="0">
-            <a:spAutoFit/>
-          </a:bodyPr>
-          <a:lstStyle/>
-          <a:p>
-            <a:pPr algn="l"/>
-            <a:r>
-              <a:rPr sz="1900" b="1" i="0">
+            <a:ext cx="4754880" cy="457200"/>
+          </a:xfrm>
+          <a:prstGeom prst="rect">
+            <a:avLst/>
+          </a:prstGeom>
+          <a:noFill/>
+        </p:spPr>
+        <p:txBody>
+          <a:bodyPr wrap="square" anchor="t" lIns="0" rIns="0" tIns="0" bIns="0">
+            <a:spAutoFit/>
+          </a:bodyPr>
+          <a:lstStyle/>
+          <a:p>
+            <a:pPr algn="l"/>
+            <a:r>
+              <a:rPr sz="1800" b="1" i="0">
                 <a:solidFill>
                   <a:srgbClr val="5F7249"/>
                 </a:solidFill>
                 <a:latin typeface="Arial"/>
               </a:rPr>
-              <a:t>High-stakes adjudication — a second, independent frontier model</a:t>
+              <a:t>It earns its place — or it retires</a:t>
             </a:r>
           </a:p>
         </p:txBody>
@@ -12906,8 +13025,8 @@
         </p:nvSpPr>
         <p:spPr>
           <a:xfrm>
-            <a:off x="6537960" y="3246120"/>
-            <a:ext cx="4754880" cy="1280160"/>
+            <a:off x="6537960" y="2651760"/>
+            <a:ext cx="4754880" cy="2103120"/>
           </a:xfrm>
           <a:prstGeom prst="rect">
             <a:avLst/>
@@ -12926,13 +13045,13 @@
               </a:spcAft>
             </a:pPr>
             <a:r>
-              <a:rPr sz="1600" b="0" i="0">
+              <a:rPr sz="1400" b="0" i="0">
                 <a:solidFill>
                   <a:srgbClr val="141413"/>
                 </a:solidFill>
                 <a:latin typeface="Arial"/>
               </a:rPr>
-              <a:t>For legal exposure, contested blame, decisions that bind people.</a:t>
+              <a:t>• every real run is logged to a use-monitor</a:t>
             </a:r>
           </a:p>
           <a:p>
@@ -12942,13 +13061,45 @@
               </a:spcAft>
             </a:pPr>
             <a:r>
-              <a:rPr sz="1600" b="1" i="0">
-                <a:solidFill>
-                  <a:srgbClr val="5F7249"/>
-                </a:solidFill>
-                <a:latin typeface="Arial"/>
-              </a:rPr>
-              <a:t>We used Fable 5 — run blind, then adversarial.</a:t>
+              <a:rPr sz="1400" b="0" i="0">
+                <a:solidFill>
+                  <a:srgbClr val="141413"/>
+                </a:solidFill>
+                <a:latin typeface="Arial"/>
+              </a:rPr>
+              <a:t>• a pre-registered, per-class rule reads the ledger</a:t>
+            </a:r>
+          </a:p>
+          <a:p>
+            <a:pPr algn="l">
+              <a:spcAft>
+                <a:spcPts val="600"/>
+              </a:spcAft>
+            </a:pPr>
+            <a:r>
+              <a:rPr sz="1400" b="0" i="0">
+                <a:solidFill>
+                  <a:srgbClr val="141413"/>
+                </a:solidFill>
+                <a:latin typeface="Arial"/>
+              </a:rPr>
+              <a:t>• no decision-relevant catches for a class over time — recommend on-request (reversible, audited)</a:t>
+            </a:r>
+          </a:p>
+          <a:p>
+            <a:pPr algn="l">
+              <a:spcAft>
+                <a:spcPts val="600"/>
+              </a:spcAft>
+            </a:pPr>
+            <a:r>
+              <a:rPr sz="1400" b="0" i="0">
+                <a:solidFill>
+                  <a:srgbClr val="141413"/>
+                </a:solidFill>
+                <a:latin typeface="Arial"/>
+              </a:rPr>
+              <a:t>• decides economic redundancy from real use, not by argument</a:t>
             </a:r>
           </a:p>
         </p:txBody>
@@ -12961,8 +13112,8 @@
         </p:nvSpPr>
         <p:spPr>
           <a:xfrm>
-            <a:off x="640080" y="4754880"/>
-            <a:ext cx="10908792" cy="1234440"/>
+            <a:off x="640080" y="5120640"/>
+            <a:ext cx="10908792" cy="1051560"/>
           </a:xfrm>
           <a:prstGeom prst="roundRect">
             <a:avLst>
@@ -13007,8 +13158,8 @@
         </p:nvSpPr>
         <p:spPr>
           <a:xfrm>
-            <a:off x="1005840" y="4754880"/>
-            <a:ext cx="10177272" cy="1234440"/>
+            <a:off x="1005840" y="5120640"/>
+            <a:ext cx="10177272" cy="1051560"/>
           </a:xfrm>
           <a:prstGeom prst="rect">
             <a:avLst/>
@@ -13023,13 +13174,25 @@
           <a:p>
             <a:pPr algn="l"/>
             <a:r>
-              <a:rPr sz="1800" b="1" i="0">
+              <a:rPr sz="1500" b="1" i="0">
                 <a:solidFill>
                   <a:srgbClr val="FFFFFF"/>
                 </a:solidFill>
                 <a:latin typeface="Arial"/>
               </a:rPr>
-              <a:t>A rigour-and-defensibility check, not a safety net: it sharpens a sound analysis, safely — but catching what the disciplined first pass missed is unproven.</a:t>
+              <a:t>You own even the boundary decision — </a:t>
+            </a:r>
+          </a:p>
+          <a:p>
+            <a:pPr algn="l"/>
+            <a:r>
+              <a:rPr sz="1500" b="1" i="0">
+                <a:solidFill>
+                  <a:srgbClr val="E89078"/>
+                </a:solidFill>
+                <a:latin typeface="Arial"/>
+              </a:rPr>
+              <a:t>and the layer steps back where it no longer adds decision value.</a:t>
             </a:r>
           </a:p>
         </p:txBody>
@@ -13064,7 +13227,7 @@
                 </a:solidFill>
                 <a:latin typeface="Arial"/>
               </a:rPr>
-              <a:t>20/26</a:t>
+              <a:t>20/27</a:t>
             </a:r>
           </a:p>
         </p:txBody>
@@ -13125,7 +13288,7 @@
                 </a:solidFill>
                 <a:latin typeface="Arial"/>
               </a:rPr>
-              <a:t>MODEL CHOICE · A WEAKER MODEL</a:t>
+              <a:t>MODEL CHOICE · WHICH MODEL, AND WHEN</a:t>
             </a:r>
           </a:p>
         </p:txBody>
@@ -13160,7 +13323,7 @@
                 </a:solidFill>
                 <a:latin typeface="Arial"/>
               </a:rPr>
-              <a:t>The engine disciplines the model — it doesn't rescue it.</a:t>
+              <a:t>Which model, and when.</a:t>
             </a:r>
           </a:p>
         </p:txBody>
@@ -13174,7 +13337,145 @@
         <p:spPr>
           <a:xfrm>
             <a:off x="640080" y="1783080"/>
-            <a:ext cx="5440680" cy="2377440"/>
+            <a:ext cx="5440680" cy="2788920"/>
+          </a:xfrm>
+          <a:prstGeom prst="roundRect">
+            <a:avLst>
+              <a:gd name="adj" fmla="val 5500"/>
+            </a:avLst>
+          </a:prstGeom>
+          <a:solidFill>
+            <a:srgbClr val="FFFFFF"/>
+          </a:solidFill>
+          <a:ln w="12700">
+            <a:solidFill>
+              <a:srgbClr val="E4E1D6"/>
+            </a:solidFill>
+          </a:ln>
+          <a:effectLst/>
+        </p:spPr>
+        <p:style>
+          <a:lnRef idx="1">
+            <a:schemeClr val="accent1"/>
+          </a:lnRef>
+          <a:fillRef idx="3">
+            <a:schemeClr val="accent1"/>
+          </a:fillRef>
+          <a:effectRef idx="2">
+            <a:schemeClr val="accent1"/>
+          </a:effectRef>
+          <a:fontRef idx="minor">
+            <a:schemeClr val="lt1"/>
+          </a:fontRef>
+        </p:style>
+        <p:txBody>
+          <a:bodyPr rtlCol="0" anchor="ctr"/>
+          <a:lstStyle/>
+          <a:p>
+            <a:pPr algn="ctr"/>
+          </a:p>
+        </p:txBody>
+      </p:sp>
+      <p:sp>
+        <p:nvSpPr>
+          <p:cNvPr id="5" name="TextBox 4"/>
+          <p:cNvSpPr txBox="1"/>
+          <p:nvPr/>
+        </p:nvSpPr>
+        <p:spPr>
+          <a:xfrm>
+            <a:off x="914400" y="2011680"/>
+            <a:ext cx="4937760" cy="822960"/>
+          </a:xfrm>
+          <a:prstGeom prst="rect">
+            <a:avLst/>
+          </a:prstGeom>
+          <a:noFill/>
+        </p:spPr>
+        <p:txBody>
+          <a:bodyPr wrap="square" anchor="t" lIns="0" rIns="0" tIns="0" bIns="0">
+            <a:spAutoFit/>
+          </a:bodyPr>
+          <a:lstStyle/>
+          <a:p>
+            <a:pPr algn="l"/>
+            <a:r>
+              <a:rPr sz="1900" b="1" i="0">
+                <a:solidFill>
+                  <a:srgbClr val="4E79A6"/>
+                </a:solidFill>
+                <a:latin typeface="Arial"/>
+              </a:rPr>
+              <a:t>Execution — a top-tier frontier model</a:t>
+            </a:r>
+          </a:p>
+        </p:txBody>
+      </p:sp>
+      <p:sp>
+        <p:nvSpPr>
+          <p:cNvPr id="6" name="TextBox 5"/>
+          <p:cNvSpPr txBox="1"/>
+          <p:nvPr/>
+        </p:nvSpPr>
+        <p:spPr>
+          <a:xfrm>
+            <a:off x="914400" y="3246120"/>
+            <a:ext cx="4937760" cy="1280160"/>
+          </a:xfrm>
+          <a:prstGeom prst="rect">
+            <a:avLst/>
+          </a:prstGeom>
+          <a:noFill/>
+        </p:spPr>
+        <p:txBody>
+          <a:bodyPr wrap="square" anchor="t" lIns="0" rIns="0" tIns="0" bIns="0">
+            <a:spAutoFit/>
+          </a:bodyPr>
+          <a:lstStyle/>
+          <a:p>
+            <a:pPr algn="l">
+              <a:spcAft>
+                <a:spcPts val="600"/>
+              </a:spcAft>
+            </a:pPr>
+            <a:r>
+              <a:rPr sz="1600" b="0" i="0">
+                <a:solidFill>
+                  <a:srgbClr val="141413"/>
+                </a:solidFill>
+                <a:latin typeface="Arial"/>
+              </a:rPr>
+              <a:t>Nearly every step leans on the model's own reasoning.</a:t>
+            </a:r>
+          </a:p>
+          <a:p>
+            <a:pPr algn="l">
+              <a:spcAft>
+                <a:spcPts val="600"/>
+              </a:spcAft>
+            </a:pPr>
+            <a:r>
+              <a:rPr sz="1600" b="1" i="0">
+                <a:solidFill>
+                  <a:srgbClr val="4E79A6"/>
+                </a:solidFill>
+                <a:latin typeface="Arial"/>
+              </a:rPr>
+              <a:t>We ran the engine on Opus 4.8.</a:t>
+            </a:r>
+          </a:p>
+        </p:txBody>
+      </p:sp>
+      <p:sp>
+        <p:nvSpPr>
+          <p:cNvPr id="7" name="Rounded Rectangle 6"/>
+          <p:cNvSpPr/>
+          <p:nvPr/>
+        </p:nvSpPr>
+        <p:spPr>
+          <a:xfrm>
+            <a:off x="6263640" y="1783080"/>
+            <a:ext cx="5285232" cy="2788920"/>
           </a:xfrm>
           <a:prstGeom prst="roundRect">
             <a:avLst>
@@ -13215,49 +13516,49 @@
       </p:sp>
       <p:sp>
         <p:nvSpPr>
-          <p:cNvPr id="5" name="TextBox 4"/>
-          <p:cNvSpPr txBox="1"/>
-          <p:nvPr/>
-        </p:nvSpPr>
-        <p:spPr>
-          <a:xfrm>
-            <a:off x="914400" y="1993392"/>
-            <a:ext cx="4937760" cy="457200"/>
-          </a:xfrm>
-          <a:prstGeom prst="rect">
-            <a:avLst/>
-          </a:prstGeom>
-          <a:noFill/>
-        </p:spPr>
-        <p:txBody>
-          <a:bodyPr wrap="square" anchor="t" lIns="0" rIns="0" tIns="0" bIns="0">
-            <a:spAutoFit/>
-          </a:bodyPr>
-          <a:lstStyle/>
-          <a:p>
-            <a:pPr algn="l"/>
-            <a:r>
-              <a:rPr sz="1800" b="1" i="0">
+          <p:cNvPr id="8" name="TextBox 7"/>
+          <p:cNvSpPr txBox="1"/>
+          <p:nvPr/>
+        </p:nvSpPr>
+        <p:spPr>
+          <a:xfrm>
+            <a:off x="6537960" y="2011680"/>
+            <a:ext cx="4754880" cy="822960"/>
+          </a:xfrm>
+          <a:prstGeom prst="rect">
+            <a:avLst/>
+          </a:prstGeom>
+          <a:noFill/>
+        </p:spPr>
+        <p:txBody>
+          <a:bodyPr wrap="square" anchor="t" lIns="0" rIns="0" tIns="0" bIns="0">
+            <a:spAutoFit/>
+          </a:bodyPr>
+          <a:lstStyle/>
+          <a:p>
+            <a:pPr algn="l"/>
+            <a:r>
+              <a:rPr sz="1900" b="1" i="0">
                 <a:solidFill>
                   <a:srgbClr val="5F7249"/>
                 </a:solidFill>
                 <a:latin typeface="Arial"/>
               </a:rPr>
-              <a:t>Survives — the scaffolding</a:t>
-            </a:r>
-          </a:p>
-        </p:txBody>
-      </p:sp>
-      <p:sp>
-        <p:nvSpPr>
-          <p:cNvPr id="6" name="TextBox 5"/>
-          <p:cNvSpPr txBox="1"/>
-          <p:nvPr/>
-        </p:nvSpPr>
-        <p:spPr>
-          <a:xfrm>
-            <a:off x="914400" y="2606040"/>
-            <a:ext cx="4937760" cy="1463040"/>
+              <a:t>High-stakes adjudication — a second, independent frontier model</a:t>
+            </a:r>
+          </a:p>
+        </p:txBody>
+      </p:sp>
+      <p:sp>
+        <p:nvSpPr>
+          <p:cNvPr id="9" name="TextBox 8"/>
+          <p:cNvSpPr txBox="1"/>
+          <p:nvPr/>
+        </p:nvSpPr>
+        <p:spPr>
+          <a:xfrm>
+            <a:off x="6537960" y="3246120"/>
+            <a:ext cx="4754880" cy="1280160"/>
           </a:xfrm>
           <a:prstGeom prst="rect">
             <a:avLst/>
@@ -13272,7 +13573,7 @@
           <a:p>
             <a:pPr algn="l">
               <a:spcAft>
-                <a:spcPts val="500"/>
+                <a:spcPts val="600"/>
               </a:spcAft>
             </a:pPr>
             <a:r>
@@ -13282,193 +13583,23 @@
                 </a:solidFill>
                 <a:latin typeface="Arial"/>
               </a:rPr>
-              <a:t>• the forced gate</a:t>
+              <a:t>For legal exposure, contested blame, decisions that bind people.</a:t>
             </a:r>
           </a:p>
           <a:p>
             <a:pPr algn="l">
               <a:spcAft>
-                <a:spcPts val="500"/>
+                <a:spcPts val="600"/>
               </a:spcAft>
             </a:pPr>
             <a:r>
-              <a:rPr sz="1600" b="0" i="0">
-                <a:solidFill>
-                  <a:srgbClr val="141413"/>
-                </a:solidFill>
-                <a:latin typeface="Arial"/>
-              </a:rPr>
-              <a:t>• grades &amp; caveats still travel</a:t>
-            </a:r>
-          </a:p>
-          <a:p>
-            <a:pPr algn="l">
-              <a:spcAft>
-                <a:spcPts val="500"/>
-              </a:spcAft>
-            </a:pPr>
-            <a:r>
-              <a:rPr sz="1600" b="0" i="0">
-                <a:solidFill>
-                  <a:srgbClr val="141413"/>
-                </a:solidFill>
-                <a:latin typeface="Arial"/>
-              </a:rPr>
-              <a:t>• audience rendering</a:t>
-            </a:r>
-          </a:p>
-        </p:txBody>
-      </p:sp>
-      <p:sp>
-        <p:nvSpPr>
-          <p:cNvPr id="7" name="Rounded Rectangle 6"/>
-          <p:cNvSpPr/>
-          <p:nvPr/>
-        </p:nvSpPr>
-        <p:spPr>
-          <a:xfrm>
-            <a:off x="6263640" y="1783080"/>
-            <a:ext cx="5285232" cy="2377440"/>
-          </a:xfrm>
-          <a:prstGeom prst="roundRect">
-            <a:avLst>
-              <a:gd name="adj" fmla="val 5500"/>
-            </a:avLst>
-          </a:prstGeom>
-          <a:solidFill>
-            <a:srgbClr val="F2DBCE"/>
-          </a:solidFill>
-          <a:ln w="12700">
-            <a:solidFill>
-              <a:srgbClr val="D97757"/>
-            </a:solidFill>
-          </a:ln>
-          <a:effectLst/>
-        </p:spPr>
-        <p:style>
-          <a:lnRef idx="1">
-            <a:schemeClr val="accent1"/>
-          </a:lnRef>
-          <a:fillRef idx="3">
-            <a:schemeClr val="accent1"/>
-          </a:fillRef>
-          <a:effectRef idx="2">
-            <a:schemeClr val="accent1"/>
-          </a:effectRef>
-          <a:fontRef idx="minor">
-            <a:schemeClr val="lt1"/>
-          </a:fontRef>
-        </p:style>
-        <p:txBody>
-          <a:bodyPr rtlCol="0" anchor="ctr"/>
-          <a:lstStyle/>
-          <a:p>
-            <a:pPr algn="ctr"/>
-          </a:p>
-        </p:txBody>
-      </p:sp>
-      <p:sp>
-        <p:nvSpPr>
-          <p:cNvPr id="8" name="TextBox 7"/>
-          <p:cNvSpPr txBox="1"/>
-          <p:nvPr/>
-        </p:nvSpPr>
-        <p:spPr>
-          <a:xfrm>
-            <a:off x="6537960" y="1993392"/>
-            <a:ext cx="4754880" cy="457200"/>
-          </a:xfrm>
-          <a:prstGeom prst="rect">
-            <a:avLst/>
-          </a:prstGeom>
-          <a:noFill/>
-        </p:spPr>
-        <p:txBody>
-          <a:bodyPr wrap="square" anchor="t" lIns="0" rIns="0" tIns="0" bIns="0">
-            <a:spAutoFit/>
-          </a:bodyPr>
-          <a:lstStyle/>
-          <a:p>
-            <a:pPr algn="l"/>
-            <a:r>
-              <a:rPr sz="1800" b="1" i="0">
-                <a:solidFill>
-                  <a:srgbClr val="D97757"/>
-                </a:solidFill>
-                <a:latin typeface="Arial"/>
-              </a:rPr>
-              <a:t>Degrades — what fills it</a:t>
-            </a:r>
-          </a:p>
-        </p:txBody>
-      </p:sp>
-      <p:sp>
-        <p:nvSpPr>
-          <p:cNvPr id="9" name="TextBox 8"/>
-          <p:cNvSpPr txBox="1"/>
-          <p:nvPr/>
-        </p:nvSpPr>
-        <p:spPr>
-          <a:xfrm>
-            <a:off x="6537960" y="2606040"/>
-            <a:ext cx="4754880" cy="1463040"/>
-          </a:xfrm>
-          <a:prstGeom prst="rect">
-            <a:avLst/>
-          </a:prstGeom>
-          <a:noFill/>
-        </p:spPr>
-        <p:txBody>
-          <a:bodyPr wrap="square" anchor="t" lIns="0" rIns="0" tIns="0" bIns="0">
-            <a:spAutoFit/>
-          </a:bodyPr>
-          <a:lstStyle/>
-          <a:p>
-            <a:pPr algn="l">
-              <a:spcAft>
-                <a:spcPts val="500"/>
-              </a:spcAft>
-            </a:pPr>
-            <a:r>
-              <a:rPr sz="1600" b="0" i="0">
-                <a:solidFill>
-                  <a:srgbClr val="141413"/>
-                </a:solidFill>
-                <a:latin typeface="Arial"/>
-              </a:rPr>
-              <a:t>• source tiers less reliable</a:t>
-            </a:r>
-          </a:p>
-          <a:p>
-            <a:pPr algn="l">
-              <a:spcAft>
-                <a:spcPts val="500"/>
-              </a:spcAft>
-            </a:pPr>
-            <a:r>
-              <a:rPr sz="1600" b="0" i="0">
-                <a:solidFill>
-                  <a:srgbClr val="141413"/>
-                </a:solidFill>
-                <a:latin typeface="Arial"/>
-              </a:rPr>
-              <a:t>• thinner counter-evidence search</a:t>
-            </a:r>
-          </a:p>
-          <a:p>
-            <a:pPr algn="l">
-              <a:spcAft>
-                <a:spcPts val="500"/>
-              </a:spcAft>
-            </a:pPr>
-            <a:r>
-              <a:rPr sz="1600" b="0" i="0">
-                <a:solidFill>
-                  <a:srgbClr val="141413"/>
-                </a:solidFill>
-                <a:latin typeface="Arial"/>
-              </a:rPr>
-              <a:t>• more confident errors, worse at catching them</a:t>
+              <a:rPr sz="1600" b="1" i="0">
+                <a:solidFill>
+                  <a:srgbClr val="5F7249"/>
+                </a:solidFill>
+                <a:latin typeface="Arial"/>
+              </a:rPr>
+              <a:t>We used Fable 5 — run blind, then adversarial.</a:t>
             </a:r>
           </a:p>
         </p:txBody>
@@ -13481,8 +13612,8 @@
         </p:nvSpPr>
         <p:spPr>
           <a:xfrm>
-            <a:off x="640080" y="4434840"/>
-            <a:ext cx="10908792" cy="1463040"/>
+            <a:off x="640080" y="4754880"/>
+            <a:ext cx="10908792" cy="1234440"/>
           </a:xfrm>
           <a:prstGeom prst="roundRect">
             <a:avLst>
@@ -13527,8 +13658,8 @@
         </p:nvSpPr>
         <p:spPr>
           <a:xfrm>
-            <a:off x="1005840" y="4434840"/>
-            <a:ext cx="10177272" cy="1463040"/>
+            <a:off x="1005840" y="4754880"/>
+            <a:ext cx="10177272" cy="1234440"/>
           </a:xfrm>
           <a:prstGeom prst="rect">
             <a:avLst/>
@@ -13543,25 +13674,13 @@
           <a:p>
             <a:pPr algn="l"/>
             <a:r>
-              <a:rPr sz="1700" b="1" i="0">
+              <a:rPr sz="1800" b="1" i="0">
                 <a:solidFill>
                   <a:srgbClr val="FFFFFF"/>
                 </a:solidFill>
                 <a:latin typeface="Arial"/>
               </a:rPr>
-              <a:t>The polish is itself a risk — grades and caveats can make a weak answer look more defensible than it is. </a:t>
-            </a:r>
-          </a:p>
-          <a:p>
-            <a:pPr algn="l"/>
-            <a:r>
-              <a:rPr sz="1700" b="1" i="0">
-                <a:solidFill>
-                  <a:srgbClr val="E89078"/>
-                </a:solidFill>
-                <a:latin typeface="Arial"/>
-              </a:rPr>
-              <a:t>The assurance is only as good as the model underneath.</a:t>
+              <a:t>A rigour-and-defensibility check, not a safety net: it sharpens a sound analysis, safely — but catching what the disciplined first pass missed is unproven.</a:t>
             </a:r>
           </a:p>
         </p:txBody>
@@ -13596,7 +13715,7 @@
                 </a:solidFill>
                 <a:latin typeface="Arial"/>
               </a:rPr>
-              <a:t>21/26</a:t>
+              <a:t>21/27</a:t>
             </a:r>
           </a:p>
         </p:txBody>
@@ -13657,7 +13776,7 @@
                 </a:solidFill>
                 <a:latin typeface="Arial"/>
               </a:rPr>
-              <a:t>THE INTERFACE</a:t>
+              <a:t>MODEL CHOICE · A WEAKER MODEL</a:t>
             </a:r>
           </a:p>
         </p:txBody>
@@ -13692,7 +13811,7 @@
                 </a:solidFill>
                 <a:latin typeface="Arial"/>
               </a:rPr>
-              <a:t>Five commands.</a:t>
+              <a:t>The engine disciplines the model — it doesn't rescue it.</a:t>
             </a:r>
           </a:p>
         </p:txBody>
@@ -13705,8 +13824,8 @@
         </p:nvSpPr>
         <p:spPr>
           <a:xfrm>
-            <a:off x="640080" y="1627632"/>
-            <a:ext cx="5303520" cy="1417320"/>
+            <a:off x="640080" y="1783080"/>
+            <a:ext cx="5440680" cy="2377440"/>
           </a:xfrm>
           <a:prstGeom prst="roundRect">
             <a:avLst>
@@ -13714,11 +13833,11 @@
             </a:avLst>
           </a:prstGeom>
           <a:solidFill>
-            <a:srgbClr val="FFFFFF"/>
+            <a:srgbClr val="EBEEE2"/>
           </a:solidFill>
           <a:ln w="12700">
             <a:solidFill>
-              <a:srgbClr val="E4E1D6"/>
+              <a:srgbClr val="5F7249"/>
             </a:solidFill>
           </a:ln>
           <a:effectLst/>
@@ -13753,29 +13872,29 @@
         </p:nvSpPr>
         <p:spPr>
           <a:xfrm>
-            <a:off x="932688" y="1828800"/>
-            <a:ext cx="4800600" cy="457200"/>
-          </a:xfrm>
-          <a:prstGeom prst="rect">
-            <a:avLst/>
-          </a:prstGeom>
-          <a:noFill/>
-        </p:spPr>
-        <p:txBody>
-          <a:bodyPr wrap="square" anchor="t" lIns="0" rIns="0" tIns="0" bIns="0">
-            <a:spAutoFit/>
-          </a:bodyPr>
-          <a:lstStyle/>
-          <a:p>
-            <a:pPr algn="l"/>
-            <a:r>
-              <a:rPr sz="1700" b="1" i="0">
-                <a:solidFill>
-                  <a:srgbClr val="4E79A6"/>
-                </a:solidFill>
-                <a:latin typeface="Consolas"/>
-              </a:rPr>
-              <a:t>/insight-engine:analyse</a:t>
+            <a:off x="914400" y="1993392"/>
+            <a:ext cx="4937760" cy="457200"/>
+          </a:xfrm>
+          <a:prstGeom prst="rect">
+            <a:avLst/>
+          </a:prstGeom>
+          <a:noFill/>
+        </p:spPr>
+        <p:txBody>
+          <a:bodyPr wrap="square" anchor="t" lIns="0" rIns="0" tIns="0" bIns="0">
+            <a:spAutoFit/>
+          </a:bodyPr>
+          <a:lstStyle/>
+          <a:p>
+            <a:pPr algn="l"/>
+            <a:r>
+              <a:rPr sz="1800" b="1" i="0">
+                <a:solidFill>
+                  <a:srgbClr val="5F7249"/>
+                </a:solidFill>
+                <a:latin typeface="Arial"/>
+              </a:rPr>
+              <a:t>Survives — the scaffolding</a:t>
             </a:r>
           </a:p>
         </p:txBody>
@@ -13788,29 +13907,65 @@
         </p:nvSpPr>
         <p:spPr>
           <a:xfrm>
-            <a:off x="932688" y="2359152"/>
-            <a:ext cx="4754880" cy="548640"/>
-          </a:xfrm>
-          <a:prstGeom prst="rect">
-            <a:avLst/>
-          </a:prstGeom>
-          <a:noFill/>
-        </p:spPr>
-        <p:txBody>
-          <a:bodyPr wrap="square" anchor="t" lIns="0" rIns="0" tIns="0" bIns="0">
-            <a:spAutoFit/>
-          </a:bodyPr>
-          <a:lstStyle/>
-          <a:p>
-            <a:pPr algn="l"/>
-            <a:r>
-              <a:rPr sz="1400" b="0" i="0">
-                <a:solidFill>
-                  <a:srgbClr val="4A453D"/>
-                </a:solidFill>
-                <a:latin typeface="Arial"/>
-              </a:rPr>
-              <a:t>Runs the whole pipeline, end to end.</a:t>
+            <a:off x="914400" y="2606040"/>
+            <a:ext cx="4937760" cy="1463040"/>
+          </a:xfrm>
+          <a:prstGeom prst="rect">
+            <a:avLst/>
+          </a:prstGeom>
+          <a:noFill/>
+        </p:spPr>
+        <p:txBody>
+          <a:bodyPr wrap="square" anchor="t" lIns="0" rIns="0" tIns="0" bIns="0">
+            <a:spAutoFit/>
+          </a:bodyPr>
+          <a:lstStyle/>
+          <a:p>
+            <a:pPr algn="l">
+              <a:spcAft>
+                <a:spcPts val="500"/>
+              </a:spcAft>
+            </a:pPr>
+            <a:r>
+              <a:rPr sz="1600" b="0" i="0">
+                <a:solidFill>
+                  <a:srgbClr val="141413"/>
+                </a:solidFill>
+                <a:latin typeface="Arial"/>
+              </a:rPr>
+              <a:t>• the forced gate</a:t>
+            </a:r>
+          </a:p>
+          <a:p>
+            <a:pPr algn="l">
+              <a:spcAft>
+                <a:spcPts val="500"/>
+              </a:spcAft>
+            </a:pPr>
+            <a:r>
+              <a:rPr sz="1600" b="0" i="0">
+                <a:solidFill>
+                  <a:srgbClr val="141413"/>
+                </a:solidFill>
+                <a:latin typeface="Arial"/>
+              </a:rPr>
+              <a:t>• grades &amp; caveats still travel</a:t>
+            </a:r>
+          </a:p>
+          <a:p>
+            <a:pPr algn="l">
+              <a:spcAft>
+                <a:spcPts val="500"/>
+              </a:spcAft>
+            </a:pPr>
+            <a:r>
+              <a:rPr sz="1600" b="0" i="0">
+                <a:solidFill>
+                  <a:srgbClr val="141413"/>
+                </a:solidFill>
+                <a:latin typeface="Arial"/>
+              </a:rPr>
+              <a:t>• audience rendering</a:t>
             </a:r>
           </a:p>
         </p:txBody>
@@ -13823,8 +13978,8 @@
         </p:nvSpPr>
         <p:spPr>
           <a:xfrm>
-            <a:off x="6190488" y="1627632"/>
-            <a:ext cx="5303520" cy="1417320"/>
+            <a:off x="6263640" y="1783080"/>
+            <a:ext cx="5285232" cy="2377440"/>
           </a:xfrm>
           <a:prstGeom prst="roundRect">
             <a:avLst>
@@ -13832,11 +13987,11 @@
             </a:avLst>
           </a:prstGeom>
           <a:solidFill>
-            <a:srgbClr val="FFFFFF"/>
+            <a:srgbClr val="F2DBCE"/>
           </a:solidFill>
           <a:ln w="12700">
             <a:solidFill>
-              <a:srgbClr val="E4E1D6"/>
+              <a:srgbClr val="D97757"/>
             </a:solidFill>
           </a:ln>
           <a:effectLst/>
@@ -13871,29 +14026,29 @@
         </p:nvSpPr>
         <p:spPr>
           <a:xfrm>
-            <a:off x="6483096" y="1828800"/>
-            <a:ext cx="4800600" cy="457200"/>
-          </a:xfrm>
-          <a:prstGeom prst="rect">
-            <a:avLst/>
-          </a:prstGeom>
-          <a:noFill/>
-        </p:spPr>
-        <p:txBody>
-          <a:bodyPr wrap="square" anchor="t" lIns="0" rIns="0" tIns="0" bIns="0">
-            <a:spAutoFit/>
-          </a:bodyPr>
-          <a:lstStyle/>
-          <a:p>
-            <a:pPr algn="l"/>
-            <a:r>
-              <a:rPr sz="1700" b="1" i="0">
-                <a:solidFill>
-                  <a:srgbClr val="4E79A6"/>
-                </a:solidFill>
-                <a:latin typeface="Consolas"/>
-              </a:rPr>
-              <a:t>/insight-engine:verify</a:t>
+            <a:off x="6537960" y="1993392"/>
+            <a:ext cx="4754880" cy="457200"/>
+          </a:xfrm>
+          <a:prstGeom prst="rect">
+            <a:avLst/>
+          </a:prstGeom>
+          <a:noFill/>
+        </p:spPr>
+        <p:txBody>
+          <a:bodyPr wrap="square" anchor="t" lIns="0" rIns="0" tIns="0" bIns="0">
+            <a:spAutoFit/>
+          </a:bodyPr>
+          <a:lstStyle/>
+          <a:p>
+            <a:pPr algn="l"/>
+            <a:r>
+              <a:rPr sz="1800" b="1" i="0">
+                <a:solidFill>
+                  <a:srgbClr val="D97757"/>
+                </a:solidFill>
+                <a:latin typeface="Arial"/>
+              </a:rPr>
+              <a:t>Degrades — what fills it</a:t>
             </a:r>
           </a:p>
         </p:txBody>
@@ -13906,29 +14061,65 @@
         </p:nvSpPr>
         <p:spPr>
           <a:xfrm>
-            <a:off x="6483096" y="2359152"/>
-            <a:ext cx="4754880" cy="548640"/>
-          </a:xfrm>
-          <a:prstGeom prst="rect">
-            <a:avLst/>
-          </a:prstGeom>
-          <a:noFill/>
-        </p:spPr>
-        <p:txBody>
-          <a:bodyPr wrap="square" anchor="t" lIns="0" rIns="0" tIns="0" bIns="0">
-            <a:spAutoFit/>
-          </a:bodyPr>
-          <a:lstStyle/>
-          <a:p>
-            <a:pPr algn="l"/>
-            <a:r>
-              <a:rPr sz="1400" b="0" i="0">
-                <a:solidFill>
-                  <a:srgbClr val="4A453D"/>
-                </a:solidFill>
-                <a:latin typeface="Arial"/>
-              </a:rPr>
-              <a:t>Fact-checks a set of claims, or a single premise.</a:t>
+            <a:off x="6537960" y="2606040"/>
+            <a:ext cx="4754880" cy="1463040"/>
+          </a:xfrm>
+          <a:prstGeom prst="rect">
+            <a:avLst/>
+          </a:prstGeom>
+          <a:noFill/>
+        </p:spPr>
+        <p:txBody>
+          <a:bodyPr wrap="square" anchor="t" lIns="0" rIns="0" tIns="0" bIns="0">
+            <a:spAutoFit/>
+          </a:bodyPr>
+          <a:lstStyle/>
+          <a:p>
+            <a:pPr algn="l">
+              <a:spcAft>
+                <a:spcPts val="500"/>
+              </a:spcAft>
+            </a:pPr>
+            <a:r>
+              <a:rPr sz="1600" b="0" i="0">
+                <a:solidFill>
+                  <a:srgbClr val="141413"/>
+                </a:solidFill>
+                <a:latin typeface="Arial"/>
+              </a:rPr>
+              <a:t>• source tiers less reliable</a:t>
+            </a:r>
+          </a:p>
+          <a:p>
+            <a:pPr algn="l">
+              <a:spcAft>
+                <a:spcPts val="500"/>
+              </a:spcAft>
+            </a:pPr>
+            <a:r>
+              <a:rPr sz="1600" b="0" i="0">
+                <a:solidFill>
+                  <a:srgbClr val="141413"/>
+                </a:solidFill>
+                <a:latin typeface="Arial"/>
+              </a:rPr>
+              <a:t>• thinner counter-evidence search</a:t>
+            </a:r>
+          </a:p>
+          <a:p>
+            <a:pPr algn="l">
+              <a:spcAft>
+                <a:spcPts val="500"/>
+              </a:spcAft>
+            </a:pPr>
+            <a:r>
+              <a:rPr sz="1600" b="0" i="0">
+                <a:solidFill>
+                  <a:srgbClr val="141413"/>
+                </a:solidFill>
+                <a:latin typeface="Arial"/>
+              </a:rPr>
+              <a:t>• more confident errors, worse at catching them</a:t>
             </a:r>
           </a:p>
         </p:txBody>
@@ -13941,8 +14132,8 @@
         </p:nvSpPr>
         <p:spPr>
           <a:xfrm>
-            <a:off x="640080" y="3200400"/>
-            <a:ext cx="5303520" cy="1417320"/>
+            <a:off x="640080" y="4434840"/>
+            <a:ext cx="10908792" cy="1463040"/>
           </a:xfrm>
           <a:prstGeom prst="roundRect">
             <a:avLst>
@@ -13950,12 +14141,10 @@
             </a:avLst>
           </a:prstGeom>
           <a:solidFill>
-            <a:srgbClr val="FFFFFF"/>
+            <a:srgbClr val="141413"/>
           </a:solidFill>
-          <a:ln w="12700">
-            <a:solidFill>
-              <a:srgbClr val="E4E1D6"/>
-            </a:solidFill>
+          <a:ln>
+            <a:noFill/>
           </a:ln>
           <a:effectLst/>
         </p:spPr>
@@ -13989,16 +14178,16 @@
         </p:nvSpPr>
         <p:spPr>
           <a:xfrm>
-            <a:off x="932688" y="3401568"/>
-            <a:ext cx="4800600" cy="457200"/>
-          </a:xfrm>
-          <a:prstGeom prst="rect">
-            <a:avLst/>
-          </a:prstGeom>
-          <a:noFill/>
-        </p:spPr>
-        <p:txBody>
-          <a:bodyPr wrap="square" anchor="t" lIns="0" rIns="0" tIns="0" bIns="0">
+            <a:off x="1005840" y="4434840"/>
+            <a:ext cx="10177272" cy="1463040"/>
+          </a:xfrm>
+          <a:prstGeom prst="rect">
+            <a:avLst/>
+          </a:prstGeom>
+          <a:noFill/>
+        </p:spPr>
+        <p:txBody>
+          <a:bodyPr wrap="square" anchor="ctr" lIns="0" rIns="0" tIns="0" bIns="0">
             <a:spAutoFit/>
           </a:bodyPr>
           <a:lstStyle/>
@@ -14007,11 +14196,23 @@
             <a:r>
               <a:rPr sz="1700" b="1" i="0">
                 <a:solidFill>
-                  <a:srgbClr val="4E79A6"/>
-                </a:solidFill>
-                <a:latin typeface="Consolas"/>
-              </a:rPr>
-              <a:t>/insight-engine:render</a:t>
+                  <a:srgbClr val="FFFFFF"/>
+                </a:solidFill>
+                <a:latin typeface="Arial"/>
+              </a:rPr>
+              <a:t>The polish is itself a risk — grades and caveats can make a weak answer look more defensible than it is. </a:t>
+            </a:r>
+          </a:p>
+          <a:p>
+            <a:pPr algn="l"/>
+            <a:r>
+              <a:rPr sz="1700" b="1" i="0">
+                <a:solidFill>
+                  <a:srgbClr val="E89078"/>
+                </a:solidFill>
+                <a:latin typeface="Arial"/>
+              </a:rPr>
+              <a:t>The assurance is only as good as the model underneath.</a:t>
             </a:r>
           </a:p>
         </p:txBody>
@@ -14019,277 +14220,6 @@
       <p:sp>
         <p:nvSpPr>
           <p:cNvPr id="12" name="TextBox 11"/>
-          <p:cNvSpPr txBox="1"/>
-          <p:nvPr/>
-        </p:nvSpPr>
-        <p:spPr>
-          <a:xfrm>
-            <a:off x="932688" y="3931920"/>
-            <a:ext cx="4754880" cy="548640"/>
-          </a:xfrm>
-          <a:prstGeom prst="rect">
-            <a:avLst/>
-          </a:prstGeom>
-          <a:noFill/>
-        </p:spPr>
-        <p:txBody>
-          <a:bodyPr wrap="square" anchor="t" lIns="0" rIns="0" tIns="0" bIns="0">
-            <a:spAutoFit/>
-          </a:bodyPr>
-          <a:lstStyle/>
-          <a:p>
-            <a:pPr algn="l"/>
-            <a:r>
-              <a:rPr sz="1400" b="0" i="0">
-                <a:solidFill>
-                  <a:srgbClr val="4A453D"/>
-                </a:solidFill>
-                <a:latin typeface="Arial"/>
-              </a:rPr>
-              <a:t>Re-voices a finished analysis for a reader — never changing a grade.</a:t>
-            </a:r>
-          </a:p>
-        </p:txBody>
-      </p:sp>
-      <p:sp>
-        <p:nvSpPr>
-          <p:cNvPr id="13" name="Rounded Rectangle 12"/>
-          <p:cNvSpPr/>
-          <p:nvPr/>
-        </p:nvSpPr>
-        <p:spPr>
-          <a:xfrm>
-            <a:off x="6190488" y="3200400"/>
-            <a:ext cx="5303520" cy="1417320"/>
-          </a:xfrm>
-          <a:prstGeom prst="roundRect">
-            <a:avLst>
-              <a:gd name="adj" fmla="val 5500"/>
-            </a:avLst>
-          </a:prstGeom>
-          <a:solidFill>
-            <a:srgbClr val="FFFFFF"/>
-          </a:solidFill>
-          <a:ln w="12700">
-            <a:solidFill>
-              <a:srgbClr val="E4E1D6"/>
-            </a:solidFill>
-          </a:ln>
-          <a:effectLst/>
-        </p:spPr>
-        <p:style>
-          <a:lnRef idx="1">
-            <a:schemeClr val="accent1"/>
-          </a:lnRef>
-          <a:fillRef idx="3">
-            <a:schemeClr val="accent1"/>
-          </a:fillRef>
-          <a:effectRef idx="2">
-            <a:schemeClr val="accent1"/>
-          </a:effectRef>
-          <a:fontRef idx="minor">
-            <a:schemeClr val="lt1"/>
-          </a:fontRef>
-        </p:style>
-        <p:txBody>
-          <a:bodyPr rtlCol="0" anchor="ctr"/>
-          <a:lstStyle/>
-          <a:p>
-            <a:pPr algn="ctr"/>
-          </a:p>
-        </p:txBody>
-      </p:sp>
-      <p:sp>
-        <p:nvSpPr>
-          <p:cNvPr id="14" name="TextBox 13"/>
-          <p:cNvSpPr txBox="1"/>
-          <p:nvPr/>
-        </p:nvSpPr>
-        <p:spPr>
-          <a:xfrm>
-            <a:off x="6483096" y="3401568"/>
-            <a:ext cx="4800600" cy="457200"/>
-          </a:xfrm>
-          <a:prstGeom prst="rect">
-            <a:avLst/>
-          </a:prstGeom>
-          <a:noFill/>
-        </p:spPr>
-        <p:txBody>
-          <a:bodyPr wrap="square" anchor="t" lIns="0" rIns="0" tIns="0" bIns="0">
-            <a:spAutoFit/>
-          </a:bodyPr>
-          <a:lstStyle/>
-          <a:p>
-            <a:pPr algn="l"/>
-            <a:r>
-              <a:rPr sz="1700" b="1" i="0">
-                <a:solidFill>
-                  <a:srgbClr val="4E79A6"/>
-                </a:solidFill>
-                <a:latin typeface="Consolas"/>
-              </a:rPr>
-              <a:t>/insight-engine:track</a:t>
-            </a:r>
-          </a:p>
-        </p:txBody>
-      </p:sp>
-      <p:sp>
-        <p:nvSpPr>
-          <p:cNvPr id="15" name="TextBox 14"/>
-          <p:cNvSpPr txBox="1"/>
-          <p:nvPr/>
-        </p:nvSpPr>
-        <p:spPr>
-          <a:xfrm>
-            <a:off x="6483096" y="3931920"/>
-            <a:ext cx="4754880" cy="548640"/>
-          </a:xfrm>
-          <a:prstGeom prst="rect">
-            <a:avLst/>
-          </a:prstGeom>
-          <a:noFill/>
-        </p:spPr>
-        <p:txBody>
-          <a:bodyPr wrap="square" anchor="t" lIns="0" rIns="0" tIns="0" bIns="0">
-            <a:spAutoFit/>
-          </a:bodyPr>
-          <a:lstStyle/>
-          <a:p>
-            <a:pPr algn="l"/>
-            <a:r>
-              <a:rPr sz="1400" b="0" i="0">
-                <a:solidFill>
-                  <a:srgbClr val="4A453D"/>
-                </a:solidFill>
-                <a:latin typeface="Arial"/>
-              </a:rPr>
-              <a:t>Keeps an investigation live as new facts arrive.</a:t>
-            </a:r>
-          </a:p>
-        </p:txBody>
-      </p:sp>
-      <p:sp>
-        <p:nvSpPr>
-          <p:cNvPr id="16" name="Rounded Rectangle 15"/>
-          <p:cNvSpPr/>
-          <p:nvPr/>
-        </p:nvSpPr>
-        <p:spPr>
-          <a:xfrm>
-            <a:off x="640080" y="4773168"/>
-            <a:ext cx="5303520" cy="1417320"/>
-          </a:xfrm>
-          <a:prstGeom prst="roundRect">
-            <a:avLst>
-              <a:gd name="adj" fmla="val 5500"/>
-            </a:avLst>
-          </a:prstGeom>
-          <a:solidFill>
-            <a:srgbClr val="FFFFFF"/>
-          </a:solidFill>
-          <a:ln w="12700">
-            <a:solidFill>
-              <a:srgbClr val="E4E1D6"/>
-            </a:solidFill>
-          </a:ln>
-          <a:effectLst/>
-        </p:spPr>
-        <p:style>
-          <a:lnRef idx="1">
-            <a:schemeClr val="accent1"/>
-          </a:lnRef>
-          <a:fillRef idx="3">
-            <a:schemeClr val="accent1"/>
-          </a:fillRef>
-          <a:effectRef idx="2">
-            <a:schemeClr val="accent1"/>
-          </a:effectRef>
-          <a:fontRef idx="minor">
-            <a:schemeClr val="lt1"/>
-          </a:fontRef>
-        </p:style>
-        <p:txBody>
-          <a:bodyPr rtlCol="0" anchor="ctr"/>
-          <a:lstStyle/>
-          <a:p>
-            <a:pPr algn="ctr"/>
-          </a:p>
-        </p:txBody>
-      </p:sp>
-      <p:sp>
-        <p:nvSpPr>
-          <p:cNvPr id="17" name="TextBox 16"/>
-          <p:cNvSpPr txBox="1"/>
-          <p:nvPr/>
-        </p:nvSpPr>
-        <p:spPr>
-          <a:xfrm>
-            <a:off x="932688" y="4974336"/>
-            <a:ext cx="4800600" cy="457200"/>
-          </a:xfrm>
-          <a:prstGeom prst="rect">
-            <a:avLst/>
-          </a:prstGeom>
-          <a:noFill/>
-        </p:spPr>
-        <p:txBody>
-          <a:bodyPr wrap="square" anchor="t" lIns="0" rIns="0" tIns="0" bIns="0">
-            <a:spAutoFit/>
-          </a:bodyPr>
-          <a:lstStyle/>
-          <a:p>
-            <a:pPr algn="l"/>
-            <a:r>
-              <a:rPr sz="1700" b="1" i="0">
-                <a:solidFill>
-                  <a:srgbClr val="4E79A6"/>
-                </a:solidFill>
-                <a:latin typeface="Consolas"/>
-              </a:rPr>
-              <a:t>/insight-engine:adjudicate</a:t>
-            </a:r>
-          </a:p>
-        </p:txBody>
-      </p:sp>
-      <p:sp>
-        <p:nvSpPr>
-          <p:cNvPr id="18" name="TextBox 17"/>
-          <p:cNvSpPr txBox="1"/>
-          <p:nvPr/>
-        </p:nvSpPr>
-        <p:spPr>
-          <a:xfrm>
-            <a:off x="932688" y="5504688"/>
-            <a:ext cx="4754880" cy="548640"/>
-          </a:xfrm>
-          <a:prstGeom prst="rect">
-            <a:avLst/>
-          </a:prstGeom>
-          <a:noFill/>
-        </p:spPr>
-        <p:txBody>
-          <a:bodyPr wrap="square" anchor="t" lIns="0" rIns="0" tIns="0" bIns="0">
-            <a:spAutoFit/>
-          </a:bodyPr>
-          <a:lstStyle/>
-          <a:p>
-            <a:pPr algn="l"/>
-            <a:r>
-              <a:rPr sz="1400" b="0" i="0">
-                <a:solidFill>
-                  <a:srgbClr val="4A453D"/>
-                </a:solidFill>
-                <a:latin typeface="Arial"/>
-              </a:rPr>
-              <a:t>Opt-in, off-by-default independent second pass (Step 10) on a finished high-stakes analysis.</a:t>
-            </a:r>
-          </a:p>
-        </p:txBody>
-      </p:sp>
-      <p:sp>
-        <p:nvSpPr>
-          <p:cNvPr id="19" name="TextBox 18"/>
           <p:cNvSpPr txBox="1"/>
           <p:nvPr/>
         </p:nvSpPr>
@@ -14317,7 +14247,7 @@
                 </a:solidFill>
                 <a:latin typeface="Arial"/>
               </a:rPr>
-              <a:t>22/26</a:t>
+              <a:t>22/27</a:t>
             </a:r>
           </a:p>
         </p:txBody>
@@ -14378,7 +14308,7 @@
                 </a:solidFill>
                 <a:latin typeface="Arial"/>
               </a:rPr>
-              <a:t>STEP 11 · RENDER</a:t>
+              <a:t>THE INTERFACE</a:t>
             </a:r>
           </a:p>
         </p:txBody>
@@ -14413,7 +14343,7 @@
                 </a:solidFill>
                 <a:latin typeface="Arial"/>
               </a:rPr>
-              <a:t>After the call: re-voice it for the reader.</a:t>
+              <a:t>Five commands.</a:t>
             </a:r>
           </a:p>
         </p:txBody>
@@ -14426,8 +14356,8 @@
         </p:nvSpPr>
         <p:spPr>
           <a:xfrm>
-            <a:off x="640080" y="1783080"/>
-            <a:ext cx="10908792" cy="2971800"/>
+            <a:off x="640080" y="1627632"/>
+            <a:ext cx="5303520" cy="1417320"/>
           </a:xfrm>
           <a:prstGeom prst="roundRect">
             <a:avLst>
@@ -14439,7 +14369,7 @@
           </a:solidFill>
           <a:ln w="12700">
             <a:solidFill>
-              <a:srgbClr val="4E79A6"/>
+              <a:srgbClr val="E4E1D6"/>
             </a:solidFill>
           </a:ln>
           <a:effectLst/>
@@ -14474,29 +14404,29 @@
         </p:nvSpPr>
         <p:spPr>
           <a:xfrm>
-            <a:off x="914400" y="2011680"/>
-            <a:ext cx="10332720" cy="548640"/>
-          </a:xfrm>
-          <a:prstGeom prst="rect">
-            <a:avLst/>
-          </a:prstGeom>
-          <a:noFill/>
-        </p:spPr>
-        <p:txBody>
-          <a:bodyPr wrap="square" anchor="t" lIns="0" rIns="0" tIns="0" bIns="0">
-            <a:spAutoFit/>
-          </a:bodyPr>
-          <a:lstStyle/>
-          <a:p>
-            <a:pPr algn="l"/>
-            <a:r>
-              <a:rPr sz="1900" b="1" i="0">
+            <a:off x="932688" y="1828800"/>
+            <a:ext cx="4800600" cy="457200"/>
+          </a:xfrm>
+          <a:prstGeom prst="rect">
+            <a:avLst/>
+          </a:prstGeom>
+          <a:noFill/>
+        </p:spPr>
+        <p:txBody>
+          <a:bodyPr wrap="square" anchor="t" lIns="0" rIns="0" tIns="0" bIns="0">
+            <a:spAutoFit/>
+          </a:bodyPr>
+          <a:lstStyle/>
+          <a:p>
+            <a:pPr algn="l"/>
+            <a:r>
+              <a:rPr sz="1700" b="1" i="0">
                 <a:solidFill>
                   <a:srgbClr val="4E79A6"/>
                 </a:solidFill>
-                <a:latin typeface="Arial"/>
-              </a:rPr>
-              <a:t>Render — for a particular reader</a:t>
+                <a:latin typeface="Consolas"/>
+              </a:rPr>
+              <a:t>/insight-engine:analyse</a:t>
             </a:r>
           </a:p>
         </p:txBody>
@@ -14509,29 +14439,29 @@
         </p:nvSpPr>
         <p:spPr>
           <a:xfrm>
-            <a:off x="914400" y="2743200"/>
-            <a:ext cx="10332720" cy="1920240"/>
-          </a:xfrm>
-          <a:prstGeom prst="rect">
-            <a:avLst/>
-          </a:prstGeom>
-          <a:noFill/>
-        </p:spPr>
-        <p:txBody>
-          <a:bodyPr wrap="square" anchor="t" lIns="0" rIns="0" tIns="0" bIns="0">
-            <a:spAutoFit/>
-          </a:bodyPr>
-          <a:lstStyle/>
-          <a:p>
-            <a:pPr algn="l"/>
-            <a:r>
-              <a:rPr sz="1600" b="0" i="0">
+            <a:off x="932688" y="2359152"/>
+            <a:ext cx="4754880" cy="548640"/>
+          </a:xfrm>
+          <a:prstGeom prst="rect">
+            <a:avLst/>
+          </a:prstGeom>
+          <a:noFill/>
+        </p:spPr>
+        <p:txBody>
+          <a:bodyPr wrap="square" anchor="t" lIns="0" rIns="0" tIns="0" bIns="0">
+            <a:spAutoFit/>
+          </a:bodyPr>
+          <a:lstStyle/>
+          <a:p>
+            <a:pPr algn="l"/>
+            <a:r>
+              <a:rPr sz="1400" b="0" i="0">
                 <a:solidFill>
                   <a:srgbClr val="4A453D"/>
                 </a:solidFill>
                 <a:latin typeface="Arial"/>
               </a:rPr>
-              <a:t>Re-voice the finished analysis for whoever must read it — a board, a regulator, opposing counsel, a family — without ever changing a claim or a grade to suit the audience, and carrying a core of caveats that no version is allowed to drop.</a:t>
+              <a:t>Runs the whole pipeline, end to end.</a:t>
             </a:r>
           </a:p>
         </p:txBody>
@@ -14544,8 +14474,8 @@
         </p:nvSpPr>
         <p:spPr>
           <a:xfrm>
-            <a:off x="640080" y="5074920"/>
-            <a:ext cx="10908792" cy="1005840"/>
+            <a:off x="6190488" y="1627632"/>
+            <a:ext cx="5303520" cy="1417320"/>
           </a:xfrm>
           <a:prstGeom prst="roundRect">
             <a:avLst>
@@ -14553,10 +14483,12 @@
             </a:avLst>
           </a:prstGeom>
           <a:solidFill>
-            <a:srgbClr val="141413"/>
+            <a:srgbClr val="FFFFFF"/>
           </a:solidFill>
-          <a:ln>
-            <a:noFill/>
+          <a:ln w="12700">
+            <a:solidFill>
+              <a:srgbClr val="E4E1D6"/>
+            </a:solidFill>
           </a:ln>
           <a:effectLst/>
         </p:spPr>
@@ -14590,29 +14522,29 @@
         </p:nvSpPr>
         <p:spPr>
           <a:xfrm>
-            <a:off x="1005840" y="5074920"/>
-            <a:ext cx="10177272" cy="1005840"/>
-          </a:xfrm>
-          <a:prstGeom prst="rect">
-            <a:avLst/>
-          </a:prstGeom>
-          <a:noFill/>
-        </p:spPr>
-        <p:txBody>
-          <a:bodyPr wrap="square" anchor="ctr" lIns="0" rIns="0" tIns="0" bIns="0">
-            <a:spAutoFit/>
-          </a:bodyPr>
-          <a:lstStyle/>
-          <a:p>
-            <a:pPr algn="l"/>
-            <a:r>
-              <a:rPr sz="1800" b="1" i="0">
-                <a:solidFill>
-                  <a:srgbClr val="FFFFFF"/>
-                </a:solidFill>
-                <a:latin typeface="Arial"/>
-              </a:rPr>
-              <a:t>A register transform only — it changes the voice, never a claim or a grade.</a:t>
+            <a:off x="6483096" y="1828800"/>
+            <a:ext cx="4800600" cy="457200"/>
+          </a:xfrm>
+          <a:prstGeom prst="rect">
+            <a:avLst/>
+          </a:prstGeom>
+          <a:noFill/>
+        </p:spPr>
+        <p:txBody>
+          <a:bodyPr wrap="square" anchor="t" lIns="0" rIns="0" tIns="0" bIns="0">
+            <a:spAutoFit/>
+          </a:bodyPr>
+          <a:lstStyle/>
+          <a:p>
+            <a:pPr algn="l"/>
+            <a:r>
+              <a:rPr sz="1700" b="1" i="0">
+                <a:solidFill>
+                  <a:srgbClr val="4E79A6"/>
+                </a:solidFill>
+                <a:latin typeface="Consolas"/>
+              </a:rPr>
+              <a:t>/insight-engine:verify</a:t>
             </a:r>
           </a:p>
         </p:txBody>
@@ -14620,6 +14552,395 @@
       <p:sp>
         <p:nvSpPr>
           <p:cNvPr id="9" name="TextBox 8"/>
+          <p:cNvSpPr txBox="1"/>
+          <p:nvPr/>
+        </p:nvSpPr>
+        <p:spPr>
+          <a:xfrm>
+            <a:off x="6483096" y="2359152"/>
+            <a:ext cx="4754880" cy="548640"/>
+          </a:xfrm>
+          <a:prstGeom prst="rect">
+            <a:avLst/>
+          </a:prstGeom>
+          <a:noFill/>
+        </p:spPr>
+        <p:txBody>
+          <a:bodyPr wrap="square" anchor="t" lIns="0" rIns="0" tIns="0" bIns="0">
+            <a:spAutoFit/>
+          </a:bodyPr>
+          <a:lstStyle/>
+          <a:p>
+            <a:pPr algn="l"/>
+            <a:r>
+              <a:rPr sz="1400" b="0" i="0">
+                <a:solidFill>
+                  <a:srgbClr val="4A453D"/>
+                </a:solidFill>
+                <a:latin typeface="Arial"/>
+              </a:rPr>
+              <a:t>Fact-checks a set of claims, or a single premise.</a:t>
+            </a:r>
+          </a:p>
+        </p:txBody>
+      </p:sp>
+      <p:sp>
+        <p:nvSpPr>
+          <p:cNvPr id="10" name="Rounded Rectangle 9"/>
+          <p:cNvSpPr/>
+          <p:nvPr/>
+        </p:nvSpPr>
+        <p:spPr>
+          <a:xfrm>
+            <a:off x="640080" y="3200400"/>
+            <a:ext cx="5303520" cy="1417320"/>
+          </a:xfrm>
+          <a:prstGeom prst="roundRect">
+            <a:avLst>
+              <a:gd name="adj" fmla="val 5500"/>
+            </a:avLst>
+          </a:prstGeom>
+          <a:solidFill>
+            <a:srgbClr val="FFFFFF"/>
+          </a:solidFill>
+          <a:ln w="12700">
+            <a:solidFill>
+              <a:srgbClr val="E4E1D6"/>
+            </a:solidFill>
+          </a:ln>
+          <a:effectLst/>
+        </p:spPr>
+        <p:style>
+          <a:lnRef idx="1">
+            <a:schemeClr val="accent1"/>
+          </a:lnRef>
+          <a:fillRef idx="3">
+            <a:schemeClr val="accent1"/>
+          </a:fillRef>
+          <a:effectRef idx="2">
+            <a:schemeClr val="accent1"/>
+          </a:effectRef>
+          <a:fontRef idx="minor">
+            <a:schemeClr val="lt1"/>
+          </a:fontRef>
+        </p:style>
+        <p:txBody>
+          <a:bodyPr rtlCol="0" anchor="ctr"/>
+          <a:lstStyle/>
+          <a:p>
+            <a:pPr algn="ctr"/>
+          </a:p>
+        </p:txBody>
+      </p:sp>
+      <p:sp>
+        <p:nvSpPr>
+          <p:cNvPr id="11" name="TextBox 10"/>
+          <p:cNvSpPr txBox="1"/>
+          <p:nvPr/>
+        </p:nvSpPr>
+        <p:spPr>
+          <a:xfrm>
+            <a:off x="932688" y="3401568"/>
+            <a:ext cx="4800600" cy="457200"/>
+          </a:xfrm>
+          <a:prstGeom prst="rect">
+            <a:avLst/>
+          </a:prstGeom>
+          <a:noFill/>
+        </p:spPr>
+        <p:txBody>
+          <a:bodyPr wrap="square" anchor="t" lIns="0" rIns="0" tIns="0" bIns="0">
+            <a:spAutoFit/>
+          </a:bodyPr>
+          <a:lstStyle/>
+          <a:p>
+            <a:pPr algn="l"/>
+            <a:r>
+              <a:rPr sz="1700" b="1" i="0">
+                <a:solidFill>
+                  <a:srgbClr val="4E79A6"/>
+                </a:solidFill>
+                <a:latin typeface="Consolas"/>
+              </a:rPr>
+              <a:t>/insight-engine:render</a:t>
+            </a:r>
+          </a:p>
+        </p:txBody>
+      </p:sp>
+      <p:sp>
+        <p:nvSpPr>
+          <p:cNvPr id="12" name="TextBox 11"/>
+          <p:cNvSpPr txBox="1"/>
+          <p:nvPr/>
+        </p:nvSpPr>
+        <p:spPr>
+          <a:xfrm>
+            <a:off x="932688" y="3931920"/>
+            <a:ext cx="4754880" cy="548640"/>
+          </a:xfrm>
+          <a:prstGeom prst="rect">
+            <a:avLst/>
+          </a:prstGeom>
+          <a:noFill/>
+        </p:spPr>
+        <p:txBody>
+          <a:bodyPr wrap="square" anchor="t" lIns="0" rIns="0" tIns="0" bIns="0">
+            <a:spAutoFit/>
+          </a:bodyPr>
+          <a:lstStyle/>
+          <a:p>
+            <a:pPr algn="l"/>
+            <a:r>
+              <a:rPr sz="1400" b="0" i="0">
+                <a:solidFill>
+                  <a:srgbClr val="4A453D"/>
+                </a:solidFill>
+                <a:latin typeface="Arial"/>
+              </a:rPr>
+              <a:t>Re-voices a finished analysis for a reader — never changing a grade.</a:t>
+            </a:r>
+          </a:p>
+        </p:txBody>
+      </p:sp>
+      <p:sp>
+        <p:nvSpPr>
+          <p:cNvPr id="13" name="Rounded Rectangle 12"/>
+          <p:cNvSpPr/>
+          <p:nvPr/>
+        </p:nvSpPr>
+        <p:spPr>
+          <a:xfrm>
+            <a:off x="6190488" y="3200400"/>
+            <a:ext cx="5303520" cy="1417320"/>
+          </a:xfrm>
+          <a:prstGeom prst="roundRect">
+            <a:avLst>
+              <a:gd name="adj" fmla="val 5500"/>
+            </a:avLst>
+          </a:prstGeom>
+          <a:solidFill>
+            <a:srgbClr val="FFFFFF"/>
+          </a:solidFill>
+          <a:ln w="12700">
+            <a:solidFill>
+              <a:srgbClr val="E4E1D6"/>
+            </a:solidFill>
+          </a:ln>
+          <a:effectLst/>
+        </p:spPr>
+        <p:style>
+          <a:lnRef idx="1">
+            <a:schemeClr val="accent1"/>
+          </a:lnRef>
+          <a:fillRef idx="3">
+            <a:schemeClr val="accent1"/>
+          </a:fillRef>
+          <a:effectRef idx="2">
+            <a:schemeClr val="accent1"/>
+          </a:effectRef>
+          <a:fontRef idx="minor">
+            <a:schemeClr val="lt1"/>
+          </a:fontRef>
+        </p:style>
+        <p:txBody>
+          <a:bodyPr rtlCol="0" anchor="ctr"/>
+          <a:lstStyle/>
+          <a:p>
+            <a:pPr algn="ctr"/>
+          </a:p>
+        </p:txBody>
+      </p:sp>
+      <p:sp>
+        <p:nvSpPr>
+          <p:cNvPr id="14" name="TextBox 13"/>
+          <p:cNvSpPr txBox="1"/>
+          <p:nvPr/>
+        </p:nvSpPr>
+        <p:spPr>
+          <a:xfrm>
+            <a:off x="6483096" y="3401568"/>
+            <a:ext cx="4800600" cy="457200"/>
+          </a:xfrm>
+          <a:prstGeom prst="rect">
+            <a:avLst/>
+          </a:prstGeom>
+          <a:noFill/>
+        </p:spPr>
+        <p:txBody>
+          <a:bodyPr wrap="square" anchor="t" lIns="0" rIns="0" tIns="0" bIns="0">
+            <a:spAutoFit/>
+          </a:bodyPr>
+          <a:lstStyle/>
+          <a:p>
+            <a:pPr algn="l"/>
+            <a:r>
+              <a:rPr sz="1700" b="1" i="0">
+                <a:solidFill>
+                  <a:srgbClr val="4E79A6"/>
+                </a:solidFill>
+                <a:latin typeface="Consolas"/>
+              </a:rPr>
+              <a:t>/insight-engine:track</a:t>
+            </a:r>
+          </a:p>
+        </p:txBody>
+      </p:sp>
+      <p:sp>
+        <p:nvSpPr>
+          <p:cNvPr id="15" name="TextBox 14"/>
+          <p:cNvSpPr txBox="1"/>
+          <p:nvPr/>
+        </p:nvSpPr>
+        <p:spPr>
+          <a:xfrm>
+            <a:off x="6483096" y="3931920"/>
+            <a:ext cx="4754880" cy="548640"/>
+          </a:xfrm>
+          <a:prstGeom prst="rect">
+            <a:avLst/>
+          </a:prstGeom>
+          <a:noFill/>
+        </p:spPr>
+        <p:txBody>
+          <a:bodyPr wrap="square" anchor="t" lIns="0" rIns="0" tIns="0" bIns="0">
+            <a:spAutoFit/>
+          </a:bodyPr>
+          <a:lstStyle/>
+          <a:p>
+            <a:pPr algn="l"/>
+            <a:r>
+              <a:rPr sz="1400" b="0" i="0">
+                <a:solidFill>
+                  <a:srgbClr val="4A453D"/>
+                </a:solidFill>
+                <a:latin typeface="Arial"/>
+              </a:rPr>
+              <a:t>Keeps an investigation live as new facts arrive.</a:t>
+            </a:r>
+          </a:p>
+        </p:txBody>
+      </p:sp>
+      <p:sp>
+        <p:nvSpPr>
+          <p:cNvPr id="16" name="Rounded Rectangle 15"/>
+          <p:cNvSpPr/>
+          <p:nvPr/>
+        </p:nvSpPr>
+        <p:spPr>
+          <a:xfrm>
+            <a:off x="640080" y="4773168"/>
+            <a:ext cx="5303520" cy="1417320"/>
+          </a:xfrm>
+          <a:prstGeom prst="roundRect">
+            <a:avLst>
+              <a:gd name="adj" fmla="val 5500"/>
+            </a:avLst>
+          </a:prstGeom>
+          <a:solidFill>
+            <a:srgbClr val="FFFFFF"/>
+          </a:solidFill>
+          <a:ln w="12700">
+            <a:solidFill>
+              <a:srgbClr val="E4E1D6"/>
+            </a:solidFill>
+          </a:ln>
+          <a:effectLst/>
+        </p:spPr>
+        <p:style>
+          <a:lnRef idx="1">
+            <a:schemeClr val="accent1"/>
+          </a:lnRef>
+          <a:fillRef idx="3">
+            <a:schemeClr val="accent1"/>
+          </a:fillRef>
+          <a:effectRef idx="2">
+            <a:schemeClr val="accent1"/>
+          </a:effectRef>
+          <a:fontRef idx="minor">
+            <a:schemeClr val="lt1"/>
+          </a:fontRef>
+        </p:style>
+        <p:txBody>
+          <a:bodyPr rtlCol="0" anchor="ctr"/>
+          <a:lstStyle/>
+          <a:p>
+            <a:pPr algn="ctr"/>
+          </a:p>
+        </p:txBody>
+      </p:sp>
+      <p:sp>
+        <p:nvSpPr>
+          <p:cNvPr id="17" name="TextBox 16"/>
+          <p:cNvSpPr txBox="1"/>
+          <p:nvPr/>
+        </p:nvSpPr>
+        <p:spPr>
+          <a:xfrm>
+            <a:off x="932688" y="4974336"/>
+            <a:ext cx="4800600" cy="457200"/>
+          </a:xfrm>
+          <a:prstGeom prst="rect">
+            <a:avLst/>
+          </a:prstGeom>
+          <a:noFill/>
+        </p:spPr>
+        <p:txBody>
+          <a:bodyPr wrap="square" anchor="t" lIns="0" rIns="0" tIns="0" bIns="0">
+            <a:spAutoFit/>
+          </a:bodyPr>
+          <a:lstStyle/>
+          <a:p>
+            <a:pPr algn="l"/>
+            <a:r>
+              <a:rPr sz="1700" b="1" i="0">
+                <a:solidFill>
+                  <a:srgbClr val="4E79A6"/>
+                </a:solidFill>
+                <a:latin typeface="Consolas"/>
+              </a:rPr>
+              <a:t>/insight-engine:adjudicate</a:t>
+            </a:r>
+          </a:p>
+        </p:txBody>
+      </p:sp>
+      <p:sp>
+        <p:nvSpPr>
+          <p:cNvPr id="18" name="TextBox 17"/>
+          <p:cNvSpPr txBox="1"/>
+          <p:nvPr/>
+        </p:nvSpPr>
+        <p:spPr>
+          <a:xfrm>
+            <a:off x="932688" y="5504688"/>
+            <a:ext cx="4754880" cy="548640"/>
+          </a:xfrm>
+          <a:prstGeom prst="rect">
+            <a:avLst/>
+          </a:prstGeom>
+          <a:noFill/>
+        </p:spPr>
+        <p:txBody>
+          <a:bodyPr wrap="square" anchor="t" lIns="0" rIns="0" tIns="0" bIns="0">
+            <a:spAutoFit/>
+          </a:bodyPr>
+          <a:lstStyle/>
+          <a:p>
+            <a:pPr algn="l"/>
+            <a:r>
+              <a:rPr sz="1400" b="0" i="0">
+                <a:solidFill>
+                  <a:srgbClr val="4A453D"/>
+                </a:solidFill>
+                <a:latin typeface="Arial"/>
+              </a:rPr>
+              <a:t>Opt-in, off-by-default independent second pass (Step 10) on a finished high-stakes analysis.</a:t>
+            </a:r>
+          </a:p>
+        </p:txBody>
+      </p:sp>
+      <p:sp>
+        <p:nvSpPr>
+          <p:cNvPr id="19" name="TextBox 18"/>
           <p:cNvSpPr txBox="1"/>
           <p:nvPr/>
         </p:nvSpPr>
@@ -14647,7 +14968,7 @@
                 </a:solidFill>
                 <a:latin typeface="Arial"/>
               </a:rPr>
-              <a:t>23/26</a:t>
+              <a:t>23/27</a:t>
             </a:r>
           </a:p>
         </p:txBody>
@@ -14704,11 +15025,11 @@
             <a:r>
               <a:rPr sz="1500" b="1" i="0">
                 <a:solidFill>
-                  <a:srgbClr val="5F7249"/>
-                </a:solidFill>
-                <a:latin typeface="Arial"/>
-              </a:rPr>
-              <a:t>STEP 12 · TRACK</a:t>
+                  <a:srgbClr val="D97757"/>
+                </a:solidFill>
+                <a:latin typeface="Arial"/>
+              </a:rPr>
+              <a:t>STEP 11 · RENDER</a:t>
             </a:r>
           </a:p>
         </p:txBody>
@@ -14743,7 +15064,7 @@
                 </a:solidFill>
                 <a:latin typeface="Arial"/>
               </a:rPr>
-              <a:t>Keep the analysis alive as facts arrive.</a:t>
+              <a:t>After the call: re-voice it for the reader.</a:t>
             </a:r>
           </a:p>
         </p:txBody>
@@ -14765,11 +15086,11 @@
             </a:avLst>
           </a:prstGeom>
           <a:solidFill>
-            <a:srgbClr val="EBEEE2"/>
+            <a:srgbClr val="FFFFFF"/>
           </a:solidFill>
           <a:ln w="12700">
             <a:solidFill>
-              <a:srgbClr val="5F7249"/>
+              <a:srgbClr val="4E79A6"/>
             </a:solidFill>
           </a:ln>
           <a:effectLst/>
@@ -14822,11 +15143,11 @@
             <a:r>
               <a:rPr sz="1900" b="1" i="0">
                 <a:solidFill>
-                  <a:srgbClr val="5F7249"/>
-                </a:solidFill>
-                <a:latin typeface="Arial"/>
-              </a:rPr>
-              <a:t>Track — as new facts arrive</a:t>
+                  <a:srgbClr val="4E79A6"/>
+                </a:solidFill>
+                <a:latin typeface="Arial"/>
+              </a:rPr>
+              <a:t>Render — for a particular reader</a:t>
             </a:r>
           </a:p>
         </p:txBody>
@@ -14861,7 +15182,7 @@
                 </a:solidFill>
                 <a:latin typeface="Arial"/>
               </a:rPr>
-              <a:t>Keep a long-running investigation alive: re-verify the grade-locked spine as fresh evidence lands, and say plainly if the call has moved. So the analysis does not simply end at the brief — it is kept current as the world changes.</a:t>
+              <a:t>Re-voice the finished analysis for whoever must read it — a board, a regulator, opposing counsel, a family — without ever changing a claim or a grade to suit the audience, and carrying a core of caveats that no version is allowed to drop.</a:t>
             </a:r>
           </a:p>
         </p:txBody>
@@ -14942,7 +15263,7 @@
                 </a:solidFill>
                 <a:latin typeface="Arial"/>
               </a:rPr>
-              <a:t>The graded spine is re-checked on every update — a living analysis, not a snapshot.</a:t>
+              <a:t>A register transform only — it changes the voice, never a claim or a grade.</a:t>
             </a:r>
           </a:p>
         </p:txBody>
@@ -14977,7 +15298,7 @@
                 </a:solidFill>
                 <a:latin typeface="Arial"/>
               </a:rPr>
-              <a:t>24/26</a:t>
+              <a:t>24/27</a:t>
             </a:r>
           </a:p>
         </p:txBody>
@@ -15038,6 +15359,336 @@
                 </a:solidFill>
                 <a:latin typeface="Arial"/>
               </a:rPr>
+              <a:t>STEP 12 · TRACK</a:t>
+            </a:r>
+          </a:p>
+        </p:txBody>
+      </p:sp>
+      <p:sp>
+        <p:nvSpPr>
+          <p:cNvPr id="3" name="TextBox 2"/>
+          <p:cNvSpPr txBox="1"/>
+          <p:nvPr/>
+        </p:nvSpPr>
+        <p:spPr>
+          <a:xfrm>
+            <a:off x="640080" y="676656"/>
+            <a:ext cx="10908792" cy="914400"/>
+          </a:xfrm>
+          <a:prstGeom prst="rect">
+            <a:avLst/>
+          </a:prstGeom>
+          <a:noFill/>
+        </p:spPr>
+        <p:txBody>
+          <a:bodyPr wrap="square" anchor="t" lIns="0" rIns="0" tIns="0" bIns="0">
+            <a:spAutoFit/>
+          </a:bodyPr>
+          <a:lstStyle/>
+          <a:p>
+            <a:pPr algn="l"/>
+            <a:r>
+              <a:rPr sz="3000" b="1" i="0">
+                <a:solidFill>
+                  <a:srgbClr val="141413"/>
+                </a:solidFill>
+                <a:latin typeface="Arial"/>
+              </a:rPr>
+              <a:t>Keep the analysis alive as facts arrive.</a:t>
+            </a:r>
+          </a:p>
+        </p:txBody>
+      </p:sp>
+      <p:sp>
+        <p:nvSpPr>
+          <p:cNvPr id="4" name="Rounded Rectangle 3"/>
+          <p:cNvSpPr/>
+          <p:nvPr/>
+        </p:nvSpPr>
+        <p:spPr>
+          <a:xfrm>
+            <a:off x="640080" y="1783080"/>
+            <a:ext cx="10908792" cy="2971800"/>
+          </a:xfrm>
+          <a:prstGeom prst="roundRect">
+            <a:avLst>
+              <a:gd name="adj" fmla="val 5500"/>
+            </a:avLst>
+          </a:prstGeom>
+          <a:solidFill>
+            <a:srgbClr val="EBEEE2"/>
+          </a:solidFill>
+          <a:ln w="12700">
+            <a:solidFill>
+              <a:srgbClr val="5F7249"/>
+            </a:solidFill>
+          </a:ln>
+          <a:effectLst/>
+        </p:spPr>
+        <p:style>
+          <a:lnRef idx="1">
+            <a:schemeClr val="accent1"/>
+          </a:lnRef>
+          <a:fillRef idx="3">
+            <a:schemeClr val="accent1"/>
+          </a:fillRef>
+          <a:effectRef idx="2">
+            <a:schemeClr val="accent1"/>
+          </a:effectRef>
+          <a:fontRef idx="minor">
+            <a:schemeClr val="lt1"/>
+          </a:fontRef>
+        </p:style>
+        <p:txBody>
+          <a:bodyPr rtlCol="0" anchor="ctr"/>
+          <a:lstStyle/>
+          <a:p>
+            <a:pPr algn="ctr"/>
+          </a:p>
+        </p:txBody>
+      </p:sp>
+      <p:sp>
+        <p:nvSpPr>
+          <p:cNvPr id="5" name="TextBox 4"/>
+          <p:cNvSpPr txBox="1"/>
+          <p:nvPr/>
+        </p:nvSpPr>
+        <p:spPr>
+          <a:xfrm>
+            <a:off x="914400" y="2011680"/>
+            <a:ext cx="10332720" cy="548640"/>
+          </a:xfrm>
+          <a:prstGeom prst="rect">
+            <a:avLst/>
+          </a:prstGeom>
+          <a:noFill/>
+        </p:spPr>
+        <p:txBody>
+          <a:bodyPr wrap="square" anchor="t" lIns="0" rIns="0" tIns="0" bIns="0">
+            <a:spAutoFit/>
+          </a:bodyPr>
+          <a:lstStyle/>
+          <a:p>
+            <a:pPr algn="l"/>
+            <a:r>
+              <a:rPr sz="1900" b="1" i="0">
+                <a:solidFill>
+                  <a:srgbClr val="5F7249"/>
+                </a:solidFill>
+                <a:latin typeface="Arial"/>
+              </a:rPr>
+              <a:t>Track — as new facts arrive</a:t>
+            </a:r>
+          </a:p>
+        </p:txBody>
+      </p:sp>
+      <p:sp>
+        <p:nvSpPr>
+          <p:cNvPr id="6" name="TextBox 5"/>
+          <p:cNvSpPr txBox="1"/>
+          <p:nvPr/>
+        </p:nvSpPr>
+        <p:spPr>
+          <a:xfrm>
+            <a:off x="914400" y="2743200"/>
+            <a:ext cx="10332720" cy="1920240"/>
+          </a:xfrm>
+          <a:prstGeom prst="rect">
+            <a:avLst/>
+          </a:prstGeom>
+          <a:noFill/>
+        </p:spPr>
+        <p:txBody>
+          <a:bodyPr wrap="square" anchor="t" lIns="0" rIns="0" tIns="0" bIns="0">
+            <a:spAutoFit/>
+          </a:bodyPr>
+          <a:lstStyle/>
+          <a:p>
+            <a:pPr algn="l"/>
+            <a:r>
+              <a:rPr sz="1600" b="0" i="0">
+                <a:solidFill>
+                  <a:srgbClr val="4A453D"/>
+                </a:solidFill>
+                <a:latin typeface="Arial"/>
+              </a:rPr>
+              <a:t>Keep a long-running investigation alive: re-verify the grade-locked spine as fresh evidence lands, and say plainly if the call has moved. So the analysis does not simply end at the brief — it is kept current as the world changes.</a:t>
+            </a:r>
+          </a:p>
+        </p:txBody>
+      </p:sp>
+      <p:sp>
+        <p:nvSpPr>
+          <p:cNvPr id="7" name="Rounded Rectangle 6"/>
+          <p:cNvSpPr/>
+          <p:nvPr/>
+        </p:nvSpPr>
+        <p:spPr>
+          <a:xfrm>
+            <a:off x="640080" y="5074920"/>
+            <a:ext cx="10908792" cy="1005840"/>
+          </a:xfrm>
+          <a:prstGeom prst="roundRect">
+            <a:avLst>
+              <a:gd name="adj" fmla="val 5500"/>
+            </a:avLst>
+          </a:prstGeom>
+          <a:solidFill>
+            <a:srgbClr val="141413"/>
+          </a:solidFill>
+          <a:ln>
+            <a:noFill/>
+          </a:ln>
+          <a:effectLst/>
+        </p:spPr>
+        <p:style>
+          <a:lnRef idx="1">
+            <a:schemeClr val="accent1"/>
+          </a:lnRef>
+          <a:fillRef idx="3">
+            <a:schemeClr val="accent1"/>
+          </a:fillRef>
+          <a:effectRef idx="2">
+            <a:schemeClr val="accent1"/>
+          </a:effectRef>
+          <a:fontRef idx="minor">
+            <a:schemeClr val="lt1"/>
+          </a:fontRef>
+        </p:style>
+        <p:txBody>
+          <a:bodyPr rtlCol="0" anchor="ctr"/>
+          <a:lstStyle/>
+          <a:p>
+            <a:pPr algn="ctr"/>
+          </a:p>
+        </p:txBody>
+      </p:sp>
+      <p:sp>
+        <p:nvSpPr>
+          <p:cNvPr id="8" name="TextBox 7"/>
+          <p:cNvSpPr txBox="1"/>
+          <p:nvPr/>
+        </p:nvSpPr>
+        <p:spPr>
+          <a:xfrm>
+            <a:off x="1005840" y="5074920"/>
+            <a:ext cx="10177272" cy="1005840"/>
+          </a:xfrm>
+          <a:prstGeom prst="rect">
+            <a:avLst/>
+          </a:prstGeom>
+          <a:noFill/>
+        </p:spPr>
+        <p:txBody>
+          <a:bodyPr wrap="square" anchor="ctr" lIns="0" rIns="0" tIns="0" bIns="0">
+            <a:spAutoFit/>
+          </a:bodyPr>
+          <a:lstStyle/>
+          <a:p>
+            <a:pPr algn="l"/>
+            <a:r>
+              <a:rPr sz="1800" b="1" i="0">
+                <a:solidFill>
+                  <a:srgbClr val="FFFFFF"/>
+                </a:solidFill>
+                <a:latin typeface="Arial"/>
+              </a:rPr>
+              <a:t>The graded spine is re-checked on every update — a living analysis, not a snapshot.</a:t>
+            </a:r>
+          </a:p>
+        </p:txBody>
+      </p:sp>
+      <p:sp>
+        <p:nvSpPr>
+          <p:cNvPr id="9" name="TextBox 8"/>
+          <p:cNvSpPr txBox="1"/>
+          <p:nvPr/>
+        </p:nvSpPr>
+        <p:spPr>
+          <a:xfrm>
+            <a:off x="10817352" y="6419088"/>
+            <a:ext cx="1005840" cy="301752"/>
+          </a:xfrm>
+          <a:prstGeom prst="rect">
+            <a:avLst/>
+          </a:prstGeom>
+          <a:noFill/>
+        </p:spPr>
+        <p:txBody>
+          <a:bodyPr wrap="square" anchor="t" lIns="0" rIns="0" tIns="0" bIns="0">
+            <a:spAutoFit/>
+          </a:bodyPr>
+          <a:lstStyle/>
+          <a:p>
+            <a:pPr algn="r"/>
+            <a:r>
+              <a:rPr sz="1100" b="0" i="0">
+                <a:solidFill>
+                  <a:srgbClr val="8A8578"/>
+                </a:solidFill>
+                <a:latin typeface="Arial"/>
+              </a:rPr>
+              <a:t>25/27</a:t>
+            </a:r>
+          </a:p>
+        </p:txBody>
+      </p:sp>
+    </p:spTree>
+  </p:cSld>
+  <p:clrMapOvr>
+    <a:masterClrMapping/>
+  </p:clrMapOvr>
+</p:sld>
+</file>
+
+<file path=ppt/slides/slide26.xml><?xml version="1.0" encoding="utf-8"?>
+<p:sld xmlns:a="http://schemas.openxmlformats.org/drawingml/2006/main" xmlns:p="http://schemas.openxmlformats.org/presentationml/2006/main" xmlns:r="http://schemas.openxmlformats.org/officeDocument/2006/relationships">
+  <p:cSld>
+    <p:bg>
+      <p:bgPr>
+        <a:solidFill>
+          <a:srgbClr val="FAF9F5"/>
+        </a:solidFill>
+        <a:effectLst/>
+      </p:bgPr>
+    </p:bg>
+    <p:spTree>
+      <p:nvGrpSpPr>
+        <p:cNvPr id="1" name=""/>
+        <p:cNvGrpSpPr/>
+        <p:nvPr/>
+      </p:nvGrpSpPr>
+      <p:grpSpPr/>
+      <p:sp>
+        <p:nvSpPr>
+          <p:cNvPr id="2" name="TextBox 1"/>
+          <p:cNvSpPr txBox="1"/>
+          <p:nvPr/>
+        </p:nvSpPr>
+        <p:spPr>
+          <a:xfrm>
+            <a:off x="658368" y="329184"/>
+            <a:ext cx="10881360" cy="365760"/>
+          </a:xfrm>
+          <a:prstGeom prst="rect">
+            <a:avLst/>
+          </a:prstGeom>
+          <a:noFill/>
+        </p:spPr>
+        <p:txBody>
+          <a:bodyPr wrap="square" anchor="t" lIns="0" rIns="0" tIns="0" bIns="0">
+            <a:spAutoFit/>
+          </a:bodyPr>
+          <a:lstStyle/>
+          <a:p>
+            <a:pPr algn="l"/>
+            <a:r>
+              <a:rPr sz="1500" b="1" i="0">
+                <a:solidFill>
+                  <a:srgbClr val="5F7249"/>
+                </a:solidFill>
+                <a:latin typeface="Arial"/>
+              </a:rPr>
               <a:t>POSITIONING · ICD 203</a:t>
             </a:r>
           </a:p>
@@ -15401,7 +16052,7 @@
                 </a:solidFill>
                 <a:latin typeface="Arial"/>
               </a:rPr>
-              <a:t>25/26</a:t>
+              <a:t>26/27</a:t>
             </a:r>
           </a:p>
         </p:txBody>
@@ -15414,7 +16065,7 @@
 </p:sld>
 </file>
 
-<file path=ppt/slides/slide26.xml><?xml version="1.0" encoding="utf-8"?>
+<file path=ppt/slides/slide27.xml><?xml version="1.0" encoding="utf-8"?>
 <p:sld xmlns:a="http://schemas.openxmlformats.org/drawingml/2006/main" xmlns:p="http://schemas.openxmlformats.org/presentationml/2006/main" xmlns:r="http://schemas.openxmlformats.org/officeDocument/2006/relationships">
   <p:cSld>
     <p:bg>
@@ -15602,7 +16253,7 @@
                 </a:solidFill>
                 <a:latin typeface="Arial"/>
               </a:rPr>
-              <a:t>26/26</a:t>
+              <a:t>27/27</a:t>
             </a:r>
           </a:p>
         </p:txBody>
@@ -16086,7 +16737,7 @@
                 </a:solidFill>
                 <a:latin typeface="Arial"/>
               </a:rPr>
-              <a:t>3/26</a:t>
+              <a:t>3/27</a:t>
             </a:r>
           </a:p>
         </p:txBody>
@@ -16664,7 +17315,7 @@
                 </a:solidFill>
                 <a:latin typeface="Arial"/>
               </a:rPr>
-              <a:t>4/26</a:t>
+              <a:t>4/27</a:t>
             </a:r>
           </a:p>
         </p:txBody>
@@ -17200,7 +17851,7 @@
                 </a:solidFill>
                 <a:latin typeface="Arial"/>
               </a:rPr>
-              <a:t>5/26</a:t>
+              <a:t>5/27</a:t>
             </a:r>
           </a:p>
         </p:txBody>
@@ -19867,7 +20518,7 @@
                 </a:solidFill>
                 <a:latin typeface="Arial"/>
               </a:rPr>
-              <a:t>6/26</a:t>
+              <a:t>6/27</a:t>
             </a:r>
           </a:p>
         </p:txBody>
@@ -20427,7 +21078,7 @@
                 </a:solidFill>
                 <a:latin typeface="Arial"/>
               </a:rPr>
-              <a:t>7/26</a:t>
+              <a:t>7/27</a:t>
             </a:r>
           </a:p>
         </p:txBody>
@@ -20818,7 +21469,7 @@
                 </a:solidFill>
                 <a:latin typeface="Arial"/>
               </a:rPr>
-              <a:t>8/26</a:t>
+              <a:t>8/27</a:t>
             </a:r>
           </a:p>
         </p:txBody>
@@ -21537,7 +22188,7 @@
                 </a:solidFill>
                 <a:latin typeface="Arial"/>
               </a:rPr>
-              <a:t>9/26</a:t>
+              <a:t>9/27</a:t>
             </a:r>
           </a:p>
         </p:txBody>

</xml_diff>

<commit_message>
Explainer v0.1.18: multi-provider refresh + slide 6/18/27 fixes
Deck (BUILD.py + regenerated pptx):
- Slide 18 adds the "Other" adjudicator option (any OpenAI-compatible
  endpoint) alongside Sol/Gemini/Grok, and corrects the verification
  honesty: OpenAI live-verified; Gemini/Grok built to spec, not yet
  live-smoked. Rung-A text trimmed so rung D no longer clips the banner.
- Title slide stamped v0.1.18.

Narration + Script:
- Slide 18: same "Other"/honesty wording in the spoken narration.
- Slide 6: the step 10/11/12 ending rewritten as a clean per-step walk
  (adjudication -> render -> track), each line matching its card;
  removes the "follow-ons" phrasing the TTS read as a stray "ONS".
- Slide 27: closing line restored to full text ("...what would change it").

card_geometry.json: card rectangles emitted by the deck build; the
input the render pipeline uses to place the highlight overlay.
</commit_message>
<xml_diff>
--- a/Presentation/Insight-Engine-Explainer.pptx
+++ b/Presentation/Insight-Engine-Explainer.pptx
@@ -1158,7 +1158,7 @@
           <a:lstStyle/>
           <a:p>
             <a:r>
-              <a:t>So how is that second pass actually invoked? As a subagent — a separate agent with its own isolated context, handed the facts and the grade-locked spine from the Anthropic model's analysis, but not that model's reasoning, so it can't anchor on it. Be clear on one thing: adjudication always uses two or more models. The different-lab model never runs on its own — it checks the work of the Anthropic frontier model that produced the analysis. It runs blind first — re-derive, and see if it reaches the same call — then adversarial: try to break the load-bearing claims and the call. It hands back a list of discrepancies, which fold in under grade-lock; you still own the final call. The rung it runs on depends on what is set up, strongest first. Strongest is a different-lab model — GPT-5.6 Sol, or GPT-5.5 while Sol is in limited preview — because a different training lineage gives the most decorrelated blind spots; it is built and live-verified, opt-in and off by default, and blocked by default for confidential or legal matters — overridable only by a deliberate, logged act. Next best is a different in-house model like Fable 5. If neither is set up, run a panel of two or more blind Opus instances and read where they diverge — a same-model cross-check, not independent adjudication. Weakest of all, a self-adversarial reset. Every rung is opt-in and costs credits or setup, so nothing runs on its own. Whichever rung it lands on, the engine should say so — because same-model agreement is stability, not proof.</a:t>
+              <a:t>So how is that second pass actually invoked? As a subagent — a separate agent with its own isolated context, handed the facts and the grade-locked spine from the Anthropic model's analysis, but not that model's reasoning, so it can't anchor on it. Be clear on one thing: adjudication always uses two or more models. The different-lab model never runs on its own — it checks the work of the Anthropic frontier model that produced the analysis. It runs blind first — re-derive, and see if it reaches the same call — then adversarial: try to break the load-bearing claims and the call. It hands back a list of discrepancies, which fold in under grade-lock; you still own the final call. The rung it runs on depends on what is set up, strongest first. Strongest is a different-lab model — GPT-5.6 Sol, Google's Gemini, xAI's Grok, or any other lab through an OpenAI-compatible endpoint — because a different training lineage gives the most decorrelated blind spots; the harness is built for all of them, though OpenAI is the one verified live, with Gemini and Grok built to each lab's current API but not yet live-smoked; it is opt-in and off by default, and blocked by default for confidential or legal matters — overridable only by a deliberate, logged act. Next best is a different in-house model like Fable 5. If neither is set up, run a panel of two or more blind Opus instances and read where they diverge — a same-model cross-check, not independent adjudication. Weakest of all, a self-adversarial reset. Every rung is opt-in and costs credits or setup, so nothing runs on its own. Whichever rung it lands on, the engine should say so — because same-model agreement is stability, not proof.</a:t>
             </a:r>
           </a:p>
         </p:txBody>
@@ -5535,7 +5535,7 @@
                 </a:solidFill>
                 <a:latin typeface="Arial"/>
               </a:rPr>
-              <a:t>An open plugin for Claude Code &amp; Cowork   ·   v0.1.17</a:t>
+              <a:t>An open plugin for Claude Code &amp; Cowork   ·   v0.1.18</a:t>
             </a:r>
           </a:p>
         </p:txBody>
@@ -11238,7 +11238,7 @@
                 </a:solidFill>
                 <a:latin typeface="Arial"/>
               </a:rPr>
-              <a:t>A · different-LAB model (configurable — GPT-5.6 Sol, Gemini, or Grok) — strongest; runs ALONGSIDE the Anthropic model, never alone. Invoked by an API call — the engine guides the set-up interactively. </a:t>
+              <a:t>A · different-LAB model (GPT-5.6 Sol, Gemini, Grok, or any OpenAI-compatible endpoint) — strongest; runs ALONGSIDE the Anthropic model, never alone. Invoked by an API call — the engine guides set-up. </a:t>
             </a:r>
             <a:r>
               <a:rPr sz="1300" b="0" i="1">
@@ -11247,7 +11247,7 @@
                 </a:solidFill>
                 <a:latin typeface="Arial"/>
               </a:rPr>
-              <a:t>Built + live-verified as a harness; opt-in, off by default; data leaves the boundary, so privileged/confidential is blocked by default — overridable only by a deliberate, logged act.</a:t>
+              <a:t>OpenAI live-verified; Gemini/Grok built to spec, not yet live-smoked; opt-in, off by default; data leaves the boundary, so privileged/confidential blocked by default — overridable by a deliberate, logged act.</a:t>
             </a:r>
           </a:p>
           <a:p>

</xml_diff>